<commit_message>
Support backlog slide: restyle KPIs, chart and stage breakdown
- KPI row: number first with one short line under it; open backlog and
  first response carry a coloured week-on-week change.
- Chart: new vs closed bars and the net-movement line now share one axis
  (no second scale), in a palette checked for colour-blind separation.
- "Where the open sit" moves above the AI summary and gains a composition
  bar; each stage tile takes its colour from that bar.
- CSAT left out: no Support-ticket CSAT responses exist in HubSpot.

Co-Authored-By: Claude Opus 5.5 <noreply@anthropic.com>
Claude-Session: https://claude.ai/code/session_01Lq5maWicgiSj2RkHzTdcCm
</commit_message>
<xml_diff>
--- a/exec-deck/output/H&L Support Backlog - New vs Closed - WC 19 Oct 2026.pptx
+++ b/exec-deck/output/H&L Support Backlog - New vs Closed - WC 19 Oct 2026.pptx
@@ -135,7 +135,7 @@
           </c:tx>
           <c:spPr>
             <a:solidFill>
-              <a:srgbClr val="6FAEBB"/>
+              <a:srgbClr val="1B8DA6"/>
             </a:solidFill>
             <a:effectLst/>
           </c:spPr>
@@ -147,9 +147,9 @@
               <a:lstStyle/>
               <a:p>
                 <a:pPr>
-                  <a:defRPr b="0" i="0" strike="noStrike" sz="650" u="none">
+                  <a:defRPr b="0" i="0" strike="noStrike" sz="700" u="none">
                     <a:solidFill>
-                      <a:srgbClr val="5E7280"/>
+                      <a:srgbClr val="3A4B57"/>
                     </a:solidFill>
                     <a:latin typeface="Poppins"/>
                   </a:defRPr>
@@ -236,7 +236,7 @@
           </c:tx>
           <c:spPr>
             <a:solidFill>
-              <a:srgbClr val="1C5765"/>
+              <a:srgbClr val="E0A458"/>
             </a:solidFill>
             <a:effectLst/>
           </c:spPr>
@@ -248,9 +248,9 @@
               <a:lstStyle/>
               <a:p>
                 <a:pPr>
-                  <a:defRPr b="0" i="0" strike="noStrike" sz="650" u="none">
+                  <a:defRPr b="0" i="0" strike="noStrike" sz="700" u="none">
                     <a:solidFill>
-                      <a:srgbClr val="5E7280"/>
+                      <a:srgbClr val="3A4B57"/>
                     </a:solidFill>
                     <a:latin typeface="Poppins"/>
                   </a:defRPr>
@@ -328,9 +328,9 @@
             <a:lstStyle/>
             <a:p>
               <a:pPr>
-                <a:defRPr b="0" i="0" strike="noStrike" sz="650" u="none">
+                <a:defRPr b="0" i="0" strike="noStrike" sz="700" u="none">
                   <a:solidFill>
-                    <a:srgbClr val="5E7280"/>
+                    <a:srgbClr val="3A4B57"/>
                   </a:solidFill>
                   <a:latin typeface="Poppins"/>
                 </a:defRPr>
@@ -345,8 +345,8 @@
           <c:showBubbleSize val="0"/>
           <c:showLeaderLines val="0"/>
         </c:dLbls>
-        <c:gapWidth val="55"/>
-        <c:overlap val="-5"/>
+        <c:gapWidth val="60"/>
+        <c:overlap val="-8"/>
         <c:axId val="2094734554"/>
         <c:axId val="2094734552"/>
         <c:axId val="2094734556"/>
@@ -369,11 +369,11 @@
           </c:tx>
           <c:spPr>
             <a:solidFill>
-              <a:srgbClr val="B4552D"/>
+              <a:srgbClr val="C2562A"/>
             </a:solidFill>
-            <a:ln w="28575" cap="flat">
+            <a:ln w="31750" cap="flat">
               <a:solidFill>
-                <a:srgbClr val="B4552D"/>
+                <a:srgbClr val="C2562A"/>
               </a:solidFill>
               <a:prstDash val="solid"/>
               <a:round/>
@@ -388,9 +388,9 @@
               <a:lstStyle/>
               <a:p>
                 <a:pPr>
-                  <a:defRPr b="0" i="0" strike="noStrike" sz="650" u="none">
+                  <a:defRPr b="0" i="0" strike="noStrike" sz="700" u="none">
                     <a:solidFill>
-                      <a:srgbClr val="5E7280"/>
+                      <a:srgbClr val="3A4B57"/>
                     </a:solidFill>
                     <a:latin typeface="Poppins"/>
                   </a:defRPr>
@@ -407,14 +407,14 @@
           </c:dLbls>
           <c:marker>
             <c:symbol val="circle"/>
-            <c:size val="7"/>
+            <c:size val="8"/>
             <c:spPr>
               <a:solidFill>
-                <a:srgbClr val="B4552D"/>
+                <a:srgbClr val="C2562A"/>
               </a:solidFill>
               <a:ln w="9525" cap="flat">
                 <a:solidFill>
-                  <a:srgbClr val="B4552D"/>
+                  <a:srgbClr val="C2562A"/>
                 </a:solidFill>
                 <a:prstDash val="solid"/>
                 <a:round/>
@@ -486,9 +486,9 @@
             <a:lstStyle/>
             <a:p>
               <a:pPr>
-                <a:defRPr b="0" i="0" strike="noStrike" sz="650" u="none">
+                <a:defRPr b="0" i="0" strike="noStrike" sz="700" u="none">
                   <a:solidFill>
-                    <a:srgbClr val="5E7280"/>
+                    <a:srgbClr val="3A4B57"/>
                   </a:solidFill>
                   <a:latin typeface="Poppins"/>
                 </a:defRPr>
@@ -504,8 +504,8 @@
           <c:showLeaderLines val="0"/>
         </c:dLbls>
         <c:marker val="1"/>
-        <c:axId val="2094734555"/>
-        <c:axId val="2094734553"/>
+        <c:axId val="2094734554"/>
+        <c:axId val="2094734552"/>
         <c:axId val="2094734556"/>
       </c:lineChart>
       <c:catAx>
@@ -533,7 +533,7 @@
           <a:lstStyle/>
           <a:p>
             <a:pPr>
-              <a:defRPr sz="750" b="0" i="0" u="none" strike="noStrike">
+              <a:defRPr sz="800" b="0" i="0" u="none" strike="noStrike">
                 <a:solidFill>
                   <a:srgbClr val="12293A"/>
                 </a:solidFill>
@@ -554,7 +554,7 @@
         <c:scaling>
           <c:orientation val="minMax"/>
           <c:max val="800"/>
-          <c:min val="0"/>
+          <c:min val="-300"/>
         </c:scaling>
         <c:delete val="0"/>
         <c:axPos val="l"/>
@@ -569,35 +569,6 @@
             </a:ln>
           </c:spPr>
         </c:majorGridlines>
-        <c:title>
-          <c:tx>
-            <c:rich>
-              <a:bodyPr/>
-              <a:lstStyle/>
-              <a:p>
-                <a:pPr>
-                  <a:defRPr sz="700" b="0" i="0" u="none" strike="noStrike">
-                    <a:solidFill>
-                      <a:srgbClr val="8FA1AC"/>
-                    </a:solidFill>
-                    <a:latin typeface="Arial"/>
-                  </a:defRPr>
-                </a:pPr>
-                <a:r>
-                  <a:rPr sz="700" b="0" i="0" u="none" strike="noStrike">
-                    <a:solidFill>
-                      <a:srgbClr val="8FA1AC"/>
-                    </a:solidFill>
-                    <a:latin typeface="Arial"/>
-                  </a:rPr>
-                  <a:t>Tickets</a:t>
-                </a:r>
-              </a:p>
-            </c:rich>
-          </c:tx>
-          <c:layout/>
-          <c:overlay val="0"/>
-        </c:title>
         <c:numFmt formatCode="General" sourceLinked="0"/>
         <c:majorTickMark val="out"/>
         <c:minorTickMark val="none"/>
@@ -629,120 +600,8 @@
         <c:crossAx val="2094734554"/>
         <c:crosses val="autoZero"/>
         <c:crossBetween val="between"/>
-        <c:majorUnit val="200"/>
+        <c:majorUnit val="100"/>
       </c:valAx>
-      <c:valAx>
-        <c:axId val="2094734553"/>
-        <c:scaling>
-          <c:orientation val="minMax"/>
-          <c:max val="300"/>
-          <c:min val="-300"/>
-        </c:scaling>
-        <c:delete val="0"/>
-        <c:axPos val="r"/>
-        <c:title>
-          <c:tx>
-            <c:rich>
-              <a:bodyPr/>
-              <a:lstStyle/>
-              <a:p>
-                <a:pPr>
-                  <a:defRPr sz="700" b="0" i="0" u="none" strike="noStrike">
-                    <a:solidFill>
-                      <a:srgbClr val="B4552D"/>
-                    </a:solidFill>
-                    <a:latin typeface="Arial"/>
-                  </a:defRPr>
-                </a:pPr>
-                <a:r>
-                  <a:rPr sz="700" b="0" i="0" u="none" strike="noStrike">
-                    <a:solidFill>
-                      <a:srgbClr val="B4552D"/>
-                    </a:solidFill>
-                    <a:latin typeface="Arial"/>
-                  </a:rPr>
-                  <a:t>Net movement</a:t>
-                </a:r>
-              </a:p>
-            </c:rich>
-          </c:tx>
-          <c:layout/>
-          <c:overlay val="0"/>
-        </c:title>
-        <c:numFmt formatCode="General" sourceLinked="0"/>
-        <c:majorTickMark val="out"/>
-        <c:minorTickMark val="none"/>
-        <c:tickLblPos val="nextTo"/>
-        <c:spPr>
-          <a:ln w="12700" cap="flat">
-            <a:solidFill>
-              <a:srgbClr val="888888"/>
-            </a:solidFill>
-            <a:prstDash val="solid"/>
-            <a:round/>
-          </a:ln>
-        </c:spPr>
-        <c:txPr>
-          <a:bodyPr/>
-          <a:lstStyle/>
-          <a:p>
-            <a:pPr>
-              <a:defRPr sz="700" b="0" i="0" u="none" strike="noStrike">
-                <a:solidFill>
-                  <a:srgbClr val="B4552D"/>
-                </a:solidFill>
-                <a:latin typeface="Poppins"/>
-              </a:defRPr>
-            </a:pPr>
-            <a:endParaRPr lang="en-US"/>
-          </a:p>
-        </c:txPr>
-        <c:crossAx val="2094734555"/>
-        <c:crosses val="max"/>
-        <c:crossBetween val="between"/>
-        <c:majorUnit val="150"/>
-      </c:valAx>
-      <c:catAx>
-        <c:axId val="2094734555"/>
-        <c:scaling>
-          <c:orientation val="minMax"/>
-        </c:scaling>
-        <c:delete val="1"/>
-        <c:axPos val="b"/>
-        <c:numFmt formatCode="General" sourceLinked="1"/>
-        <c:majorTickMark val="out"/>
-        <c:minorTickMark val="none"/>
-        <c:tickLblPos val="low"/>
-        <c:spPr>
-          <a:ln w="12700" cap="flat">
-            <a:solidFill>
-              <a:srgbClr val="888888"/>
-            </a:solidFill>
-            <a:prstDash val="solid"/>
-            <a:round/>
-          </a:ln>
-        </c:spPr>
-        <c:txPr>
-          <a:bodyPr/>
-          <a:lstStyle/>
-          <a:p>
-            <a:pPr>
-              <a:defRPr sz="1200" b="0" i="0" u="none" strike="noStrike">
-                <a:solidFill>
-                  <a:srgbClr val="000000"/>
-                </a:solidFill>
-                <a:latin typeface="Arial"/>
-              </a:defRPr>
-            </a:pPr>
-            <a:endParaRPr lang="en-US"/>
-          </a:p>
-        </c:txPr>
-        <c:crossAx val="2094734553"/>
-        <c:crosses val="autoZero"/>
-        <c:auto val="1"/>
-        <c:lblAlgn val="ctr"/>
-        <c:noMultiLvlLbl val="1"/>
-      </c:catAx>
       <c:spPr>
         <a:noFill/>
         <a:ln>
@@ -759,9 +618,9 @@
         <a:lstStyle/>
         <a:p>
           <a:pPr>
-            <a:defRPr sz="750">
+            <a:defRPr sz="800">
               <a:solidFill>
-                <a:srgbClr val="5E7280"/>
+                <a:srgbClr val="3A4B57"/>
               </a:solidFill>
               <a:latin typeface="Poppins"/>
               <a:cs typeface="Poppins"/>
@@ -1871,11 +1730,11 @@
         <p:spPr>
           <a:xfrm>
             <a:off x="411480" y="1024128"/>
-            <a:ext cx="2697480" cy="1143000"/>
+            <a:ext cx="2704338" cy="1051560"/>
           </a:xfrm>
           <a:prstGeom prst="roundRect">
             <a:avLst>
-              <a:gd name="adj" fmla="val 5600"/>
+              <a:gd name="adj" fmla="val 6087"/>
             </a:avLst>
           </a:prstGeom>
           <a:solidFill>
@@ -1893,14 +1752,34 @@
       </p:sp>
       <p:sp>
         <p:nvSpPr>
-          <p:cNvPr id="14" name="Text 12"/>
+          <p:cNvPr id="14" name="Shape 12"/>
+          <p:cNvSpPr/>
+          <p:nvPr/>
+        </p:nvSpPr>
+        <p:spPr>
+          <a:xfrm>
+            <a:off x="576072" y="1152144"/>
+            <a:ext cx="292608" cy="41148"/>
+          </a:xfrm>
+          <a:prstGeom prst="rect">
+            <a:avLst/>
+          </a:prstGeom>
+          <a:solidFill>
+            <a:srgbClr val="1B8DA6"/>
+          </a:solidFill>
+          <a:ln/>
+        </p:spPr>
+      </p:sp>
+      <p:sp>
+        <p:nvSpPr>
+          <p:cNvPr id="15" name="Text 13"/>
           <p:cNvSpPr txBox="1"/>
           <p:nvPr/>
         </p:nvSpPr>
         <p:spPr>
           <a:xfrm>
-            <a:off x="576072" y="1115568"/>
-            <a:ext cx="2368296" cy="274320"/>
+            <a:off x="576072" y="1225296"/>
+            <a:ext cx="2430018" cy="219456"/>
           </a:xfrm>
           <a:prstGeom prst="rect">
             <a:avLst/>
@@ -1916,9 +1795,9 @@
               <a:buNone/>
             </a:pPr>
             <a:r>
-              <a:rPr lang="en-US" sz="950" b="1" dirty="0">
-                <a:solidFill>
-                  <a:srgbClr val="2C8394"/>
+              <a:rPr lang="en-US" sz="850" b="1" dirty="0">
+                <a:solidFill>
+                  <a:srgbClr val="5E7280"/>
                 </a:solidFill>
                 <a:latin typeface="Poppins" pitchFamily="34" charset="0"/>
                 <a:ea typeface="Poppins" pitchFamily="34" charset="-122"/>
@@ -1926,20 +1805,20 @@
               </a:rPr>
               <a:t>OPEN BACKLOG</a:t>
             </a:r>
-            <a:endParaRPr lang="en-US" sz="950" dirty="0"/>
+            <a:endParaRPr lang="en-US" sz="850" dirty="0"/>
           </a:p>
         </p:txBody>
       </p:sp>
       <p:sp>
         <p:nvSpPr>
-          <p:cNvPr id="15" name="Text 13"/>
+          <p:cNvPr id="16" name="Text 14"/>
           <p:cNvSpPr txBox="1"/>
           <p:nvPr/>
         </p:nvSpPr>
         <p:spPr>
           <a:xfrm>
-            <a:off x="557784" y="1298448"/>
-            <a:ext cx="2404872" cy="356616"/>
+            <a:off x="557784" y="1444752"/>
+            <a:ext cx="2430018" cy="384048"/>
           </a:xfrm>
           <a:prstGeom prst="rect">
             <a:avLst/>
@@ -1955,9 +1834,9 @@
               <a:buNone/>
             </a:pPr>
             <a:r>
-              <a:rPr lang="en-US" sz="2600" b="1" dirty="0">
-                <a:solidFill>
-                  <a:srgbClr val="B4552D"/>
+              <a:rPr lang="en-US" sz="2400" b="1" dirty="0">
+                <a:solidFill>
+                  <a:srgbClr val="12293A"/>
                 </a:solidFill>
                 <a:latin typeface="Poppins" pitchFamily="34" charset="0"/>
                 <a:ea typeface="Poppins" pitchFamily="34" charset="-122"/>
@@ -1965,20 +1844,20 @@
               </a:rPr>
               <a:t>389</a:t>
             </a:r>
-            <a:endParaRPr lang="en-US" sz="2600" dirty="0"/>
+            <a:endParaRPr lang="en-US" sz="2400" dirty="0"/>
           </a:p>
         </p:txBody>
       </p:sp>
       <p:sp>
         <p:nvSpPr>
-          <p:cNvPr id="16" name="Text 14"/>
+          <p:cNvPr id="17" name="Text 15"/>
           <p:cNvSpPr txBox="1"/>
           <p:nvPr/>
         </p:nvSpPr>
         <p:spPr>
           <a:xfrm>
-            <a:off x="576072" y="1691640"/>
-            <a:ext cx="2368296" cy="420624"/>
+            <a:off x="576072" y="1810512"/>
+            <a:ext cx="2430018" cy="201168"/>
           </a:xfrm>
           <a:prstGeom prst="rect">
             <a:avLst/>
@@ -1987,41 +1866,41 @@
           <a:ln/>
         </p:spPr>
         <p:txBody>
-          <a:bodyPr wrap="square" lIns="0" tIns="0" rIns="0" bIns="0" rtlCol="0" anchor="t"/>
+          <a:bodyPr wrap="square" lIns="0" tIns="0" rIns="0" bIns="0" rtlCol="0" anchor="ctr"/>
           <a:lstStyle/>
           <a:p>
             <a:pPr indent="0" marL="0">
               <a:buNone/>
             </a:pPr>
             <a:r>
-              <a:rPr lang="en-US" sz="780" dirty="0">
-                <a:solidFill>
-                  <a:srgbClr val="5E7280"/>
-                </a:solidFill>
-                <a:latin typeface="Poppins" pitchFamily="34" charset="0"/>
-                <a:ea typeface="Poppins" pitchFamily="34" charset="-122"/>
-                <a:cs typeface="Poppins" pitchFamily="34" charset="-120"/>
-              </a:rPr>
-              <a:t>as at Sun 25 Oct · 588 a week ago</a:t>
-            </a:r>
-            <a:endParaRPr lang="en-US" sz="780" dirty="0"/>
+              <a:rPr lang="en-US" sz="750" b="1" dirty="0">
+                <a:solidFill>
+                  <a:srgbClr val="3D8F5F"/>
+                </a:solidFill>
+                <a:latin typeface="Poppins" pitchFamily="34" charset="0"/>
+                <a:ea typeface="Poppins" pitchFamily="34" charset="-122"/>
+                <a:cs typeface="Poppins" pitchFamily="34" charset="-120"/>
+              </a:rPr>
+              <a:t>▼ 199 vs last week</a:t>
+            </a:r>
+            <a:endParaRPr lang="en-US" sz="750" dirty="0"/>
           </a:p>
         </p:txBody>
       </p:sp>
       <p:sp>
         <p:nvSpPr>
-          <p:cNvPr id="17" name="Shape 15"/>
+          <p:cNvPr id="18" name="Shape 16"/>
           <p:cNvSpPr/>
           <p:nvPr/>
         </p:nvSpPr>
         <p:spPr>
           <a:xfrm>
-            <a:off x="3291840" y="1024128"/>
-            <a:ext cx="2697480" cy="1143000"/>
+            <a:off x="3298698" y="1024128"/>
+            <a:ext cx="2704338" cy="1051560"/>
           </a:xfrm>
           <a:prstGeom prst="roundRect">
             <a:avLst>
-              <a:gd name="adj" fmla="val 5600"/>
+              <a:gd name="adj" fmla="val 6087"/>
             </a:avLst>
           </a:prstGeom>
           <a:solidFill>
@@ -2039,14 +1918,34 @@
       </p:sp>
       <p:sp>
         <p:nvSpPr>
-          <p:cNvPr id="18" name="Text 16"/>
+          <p:cNvPr id="19" name="Shape 17"/>
+          <p:cNvSpPr/>
+          <p:nvPr/>
+        </p:nvSpPr>
+        <p:spPr>
+          <a:xfrm>
+            <a:off x="3463290" y="1152144"/>
+            <a:ext cx="292608" cy="41148"/>
+          </a:xfrm>
+          <a:prstGeom prst="rect">
+            <a:avLst/>
+          </a:prstGeom>
+          <a:solidFill>
+            <a:srgbClr val="1B8DA6"/>
+          </a:solidFill>
+          <a:ln/>
+        </p:spPr>
+      </p:sp>
+      <p:sp>
+        <p:nvSpPr>
+          <p:cNvPr id="20" name="Text 18"/>
           <p:cNvSpPr txBox="1"/>
           <p:nvPr/>
         </p:nvSpPr>
         <p:spPr>
           <a:xfrm>
-            <a:off x="3456432" y="1115568"/>
-            <a:ext cx="2368296" cy="274320"/>
+            <a:off x="3463290" y="1225296"/>
+            <a:ext cx="2430018" cy="219456"/>
           </a:xfrm>
           <a:prstGeom prst="rect">
             <a:avLst/>
@@ -2062,9 +1961,9 @@
               <a:buNone/>
             </a:pPr>
             <a:r>
-              <a:rPr lang="en-US" sz="950" b="1" dirty="0">
-                <a:solidFill>
-                  <a:srgbClr val="2C8394"/>
+              <a:rPr lang="en-US" sz="850" b="1" dirty="0">
+                <a:solidFill>
+                  <a:srgbClr val="5E7280"/>
                 </a:solidFill>
                 <a:latin typeface="Poppins" pitchFamily="34" charset="0"/>
                 <a:ea typeface="Poppins" pitchFamily="34" charset="-122"/>
@@ -2072,20 +1971,20 @@
               </a:rPr>
               <a:t>MEDIAN TICKET AGE</a:t>
             </a:r>
-            <a:endParaRPr lang="en-US" sz="950" dirty="0"/>
+            <a:endParaRPr lang="en-US" sz="850" dirty="0"/>
           </a:p>
         </p:txBody>
       </p:sp>
       <p:sp>
         <p:nvSpPr>
-          <p:cNvPr id="19" name="Text 17"/>
+          <p:cNvPr id="21" name="Text 19"/>
           <p:cNvSpPr txBox="1"/>
           <p:nvPr/>
         </p:nvSpPr>
         <p:spPr>
           <a:xfrm>
-            <a:off x="3438144" y="1298448"/>
-            <a:ext cx="2404872" cy="356616"/>
+            <a:off x="3445002" y="1444752"/>
+            <a:ext cx="2430018" cy="384048"/>
           </a:xfrm>
           <a:prstGeom prst="rect">
             <a:avLst/>
@@ -2101,9 +2000,9 @@
               <a:buNone/>
             </a:pPr>
             <a:r>
-              <a:rPr lang="en-US" sz="2600" b="1" dirty="0">
-                <a:solidFill>
-                  <a:srgbClr val="B4552D"/>
+              <a:rPr lang="en-US" sz="2400" b="1" dirty="0">
+                <a:solidFill>
+                  <a:srgbClr val="12293A"/>
                 </a:solidFill>
                 <a:latin typeface="Poppins" pitchFamily="34" charset="0"/>
                 <a:ea typeface="Poppins" pitchFamily="34" charset="-122"/>
@@ -2111,20 +2010,20 @@
               </a:rPr>
               <a:t>31 Days</a:t>
             </a:r>
-            <a:endParaRPr lang="en-US" sz="2600" dirty="0"/>
+            <a:endParaRPr lang="en-US" sz="2400" dirty="0"/>
           </a:p>
         </p:txBody>
       </p:sp>
       <p:sp>
         <p:nvSpPr>
-          <p:cNvPr id="20" name="Text 18"/>
+          <p:cNvPr id="22" name="Text 20"/>
           <p:cNvSpPr txBox="1"/>
           <p:nvPr/>
         </p:nvSpPr>
         <p:spPr>
           <a:xfrm>
-            <a:off x="3456432" y="1691640"/>
-            <a:ext cx="2368296" cy="420624"/>
+            <a:off x="3463290" y="1810512"/>
+            <a:ext cx="2430018" cy="201168"/>
           </a:xfrm>
           <a:prstGeom prst="rect">
             <a:avLst/>
@@ -2133,41 +2032,41 @@
           <a:ln/>
         </p:spPr>
         <p:txBody>
-          <a:bodyPr wrap="square" lIns="0" tIns="0" rIns="0" bIns="0" rtlCol="0" anchor="t"/>
+          <a:bodyPr wrap="square" lIns="0" tIns="0" rIns="0" bIns="0" rtlCol="0" anchor="ctr"/>
           <a:lstStyle/>
           <a:p>
             <a:pPr indent="0" marL="0">
               <a:buNone/>
             </a:pPr>
             <a:r>
-              <a:rPr lang="en-US" sz="780" dirty="0">
-                <a:solidFill>
-                  <a:srgbClr val="5E7280"/>
-                </a:solidFill>
-                <a:latin typeface="Poppins" pitchFamily="34" charset="0"/>
-                <a:ea typeface="Poppins" pitchFamily="34" charset="-122"/>
-                <a:cs typeface="Poppins" pitchFamily="34" charset="-120"/>
-              </a:rPr>
-              <a:t>all open tickets · median created 24 Sep</a:t>
-            </a:r>
-            <a:endParaRPr lang="en-US" sz="780" dirty="0"/>
+              <a:rPr lang="en-US" sz="750" dirty="0">
+                <a:solidFill>
+                  <a:srgbClr val="8FA1AC"/>
+                </a:solidFill>
+                <a:latin typeface="Poppins" pitchFamily="34" charset="0"/>
+                <a:ea typeface="Poppins" pitchFamily="34" charset="-122"/>
+                <a:cs typeface="Poppins" pitchFamily="34" charset="-120"/>
+              </a:rPr>
+              <a:t>open tickets</a:t>
+            </a:r>
+            <a:endParaRPr lang="en-US" sz="750" dirty="0"/>
           </a:p>
         </p:txBody>
       </p:sp>
       <p:sp>
         <p:nvSpPr>
-          <p:cNvPr id="21" name="Shape 19"/>
+          <p:cNvPr id="23" name="Shape 21"/>
           <p:cNvSpPr/>
           <p:nvPr/>
         </p:nvSpPr>
         <p:spPr>
           <a:xfrm>
-            <a:off x="6172200" y="1024128"/>
-            <a:ext cx="2697480" cy="1143000"/>
+            <a:off x="6185916" y="1024128"/>
+            <a:ext cx="2704338" cy="1051560"/>
           </a:xfrm>
           <a:prstGeom prst="roundRect">
             <a:avLst>
-              <a:gd name="adj" fmla="val 5600"/>
+              <a:gd name="adj" fmla="val 6087"/>
             </a:avLst>
           </a:prstGeom>
           <a:solidFill>
@@ -2185,14 +2084,34 @@
       </p:sp>
       <p:sp>
         <p:nvSpPr>
-          <p:cNvPr id="22" name="Text 20"/>
+          <p:cNvPr id="24" name="Shape 22"/>
+          <p:cNvSpPr/>
+          <p:nvPr/>
+        </p:nvSpPr>
+        <p:spPr>
+          <a:xfrm>
+            <a:off x="6350508" y="1152144"/>
+            <a:ext cx="292608" cy="41148"/>
+          </a:xfrm>
+          <a:prstGeom prst="rect">
+            <a:avLst/>
+          </a:prstGeom>
+          <a:solidFill>
+            <a:srgbClr val="1B8DA6"/>
+          </a:solidFill>
+          <a:ln/>
+        </p:spPr>
+      </p:sp>
+      <p:sp>
+        <p:nvSpPr>
+          <p:cNvPr id="25" name="Text 23"/>
           <p:cNvSpPr txBox="1"/>
           <p:nvPr/>
         </p:nvSpPr>
         <p:spPr>
           <a:xfrm>
-            <a:off x="6336792" y="1115568"/>
-            <a:ext cx="2368296" cy="274320"/>
+            <a:off x="6350508" y="1225296"/>
+            <a:ext cx="2430018" cy="219456"/>
           </a:xfrm>
           <a:prstGeom prst="rect">
             <a:avLst/>
@@ -2208,30 +2127,30 @@
               <a:buNone/>
             </a:pPr>
             <a:r>
-              <a:rPr lang="en-US" sz="950" b="1" dirty="0">
-                <a:solidFill>
-                  <a:srgbClr val="2C8394"/>
-                </a:solidFill>
-                <a:latin typeface="Poppins" pitchFamily="34" charset="0"/>
-                <a:ea typeface="Poppins" pitchFamily="34" charset="-122"/>
-                <a:cs typeface="Poppins" pitchFamily="34" charset="-120"/>
-              </a:rPr>
-              <a:t>AVG TIME TO FIRST RESPONSE</a:t>
-            </a:r>
-            <a:endParaRPr lang="en-US" sz="950" dirty="0"/>
+              <a:rPr lang="en-US" sz="850" b="1" dirty="0">
+                <a:solidFill>
+                  <a:srgbClr val="5E7280"/>
+                </a:solidFill>
+                <a:latin typeface="Poppins" pitchFamily="34" charset="0"/>
+                <a:ea typeface="Poppins" pitchFamily="34" charset="-122"/>
+                <a:cs typeface="Poppins" pitchFamily="34" charset="-120"/>
+              </a:rPr>
+              <a:t>AVG FIRST RESPONSE</a:t>
+            </a:r>
+            <a:endParaRPr lang="en-US" sz="850" dirty="0"/>
           </a:p>
         </p:txBody>
       </p:sp>
       <p:sp>
         <p:nvSpPr>
-          <p:cNvPr id="23" name="Text 21"/>
+          <p:cNvPr id="26" name="Text 24"/>
           <p:cNvSpPr txBox="1"/>
           <p:nvPr/>
         </p:nvSpPr>
         <p:spPr>
           <a:xfrm>
-            <a:off x="6318504" y="1298448"/>
-            <a:ext cx="2404872" cy="356616"/>
+            <a:off x="6332220" y="1444752"/>
+            <a:ext cx="2430018" cy="384048"/>
           </a:xfrm>
           <a:prstGeom prst="rect">
             <a:avLst/>
@@ -2247,7 +2166,7 @@
               <a:buNone/>
             </a:pPr>
             <a:r>
-              <a:rPr lang="en-US" sz="2600" b="1" dirty="0">
+              <a:rPr lang="en-US" sz="2400" b="1" dirty="0">
                 <a:solidFill>
                   <a:srgbClr val="12293A"/>
                 </a:solidFill>
@@ -2255,22 +2174,22 @@
                 <a:ea typeface="Poppins" pitchFamily="34" charset="-122"/>
                 <a:cs typeface="Poppins" pitchFamily="34" charset="-120"/>
               </a:rPr>
-              <a:t>14.7 Hours</a:t>
-            </a:r>
-            <a:endParaRPr lang="en-US" sz="2600" dirty="0"/>
+              <a:t>14.7 Hrs</a:t>
+            </a:r>
+            <a:endParaRPr lang="en-US" sz="2400" dirty="0"/>
           </a:p>
         </p:txBody>
       </p:sp>
       <p:sp>
         <p:nvSpPr>
-          <p:cNvPr id="24" name="Text 22"/>
+          <p:cNvPr id="27" name="Text 25"/>
           <p:cNvSpPr txBox="1"/>
           <p:nvPr/>
         </p:nvSpPr>
         <p:spPr>
           <a:xfrm>
-            <a:off x="6336792" y="1691640"/>
-            <a:ext cx="2368296" cy="420624"/>
+            <a:off x="6350508" y="1810512"/>
+            <a:ext cx="2430018" cy="201168"/>
           </a:xfrm>
           <a:prstGeom prst="rect">
             <a:avLst/>
@@ -2279,41 +2198,41 @@
           <a:ln/>
         </p:spPr>
         <p:txBody>
-          <a:bodyPr wrap="square" lIns="0" tIns="0" rIns="0" bIns="0" rtlCol="0" anchor="t"/>
+          <a:bodyPr wrap="square" lIns="0" tIns="0" rIns="0" bIns="0" rtlCol="0" anchor="ctr"/>
           <a:lstStyle/>
           <a:p>
             <a:pPr indent="0" marL="0">
               <a:buNone/>
             </a:pPr>
             <a:r>
-              <a:rPr lang="en-US" sz="780" dirty="0">
-                <a:solidFill>
-                  <a:srgbClr val="5E7280"/>
-                </a:solidFill>
-                <a:latin typeface="Poppins" pitchFamily="34" charset="0"/>
-                <a:ea typeface="Poppins" pitchFamily="34" charset="-122"/>
-                <a:cs typeface="Poppins" pitchFamily="34" charset="-120"/>
-              </a:rPr>
-              <a:t>median 12.1h · 55 of 396 new tickets have an email reply so far · last week 46.8h</a:t>
-            </a:r>
-            <a:endParaRPr lang="en-US" sz="780" dirty="0"/>
+              <a:rPr lang="en-US" sz="750" b="1" dirty="0">
+                <a:solidFill>
+                  <a:srgbClr val="3D8F5F"/>
+                </a:solidFill>
+                <a:latin typeface="Poppins" pitchFamily="34" charset="0"/>
+                <a:ea typeface="Poppins" pitchFamily="34" charset="-122"/>
+                <a:cs typeface="Poppins" pitchFamily="34" charset="-120"/>
+              </a:rPr>
+              <a:t>▼ from 46.8 hrs last week</a:t>
+            </a:r>
+            <a:endParaRPr lang="en-US" sz="750" dirty="0"/>
           </a:p>
         </p:txBody>
       </p:sp>
       <p:sp>
         <p:nvSpPr>
-          <p:cNvPr id="25" name="Shape 23"/>
+          <p:cNvPr id="28" name="Shape 26"/>
           <p:cNvSpPr/>
           <p:nvPr/>
         </p:nvSpPr>
         <p:spPr>
           <a:xfrm>
-            <a:off x="9052560" y="1024128"/>
-            <a:ext cx="2724912" cy="1143000"/>
+            <a:off x="9073134" y="1024128"/>
+            <a:ext cx="2704338" cy="1051560"/>
           </a:xfrm>
           <a:prstGeom prst="roundRect">
             <a:avLst>
-              <a:gd name="adj" fmla="val 5600"/>
+              <a:gd name="adj" fmla="val 6087"/>
             </a:avLst>
           </a:prstGeom>
           <a:solidFill>
@@ -2331,14 +2250,34 @@
       </p:sp>
       <p:sp>
         <p:nvSpPr>
-          <p:cNvPr id="26" name="Text 24"/>
+          <p:cNvPr id="29" name="Shape 27"/>
+          <p:cNvSpPr/>
+          <p:nvPr/>
+        </p:nvSpPr>
+        <p:spPr>
+          <a:xfrm>
+            <a:off x="9237726" y="1152144"/>
+            <a:ext cx="292608" cy="41148"/>
+          </a:xfrm>
+          <a:prstGeom prst="rect">
+            <a:avLst/>
+          </a:prstGeom>
+          <a:solidFill>
+            <a:srgbClr val="1B8DA6"/>
+          </a:solidFill>
+          <a:ln/>
+        </p:spPr>
+      </p:sp>
+      <p:sp>
+        <p:nvSpPr>
+          <p:cNvPr id="30" name="Text 28"/>
           <p:cNvSpPr txBox="1"/>
           <p:nvPr/>
         </p:nvSpPr>
         <p:spPr>
           <a:xfrm>
-            <a:off x="9217152" y="1115568"/>
-            <a:ext cx="2395728" cy="274320"/>
+            <a:off x="9237726" y="1225296"/>
+            <a:ext cx="2430018" cy="219456"/>
           </a:xfrm>
           <a:prstGeom prst="rect">
             <a:avLst/>
@@ -2354,9 +2293,9 @@
               <a:buNone/>
             </a:pPr>
             <a:r>
-              <a:rPr lang="en-US" sz="950" b="1" dirty="0">
-                <a:solidFill>
-                  <a:srgbClr val="2C8394"/>
+              <a:rPr lang="en-US" sz="850" b="1" dirty="0">
+                <a:solidFill>
+                  <a:srgbClr val="5E7280"/>
                 </a:solidFill>
                 <a:latin typeface="Poppins" pitchFamily="34" charset="0"/>
                 <a:ea typeface="Poppins" pitchFamily="34" charset="-122"/>
@@ -2364,20 +2303,20 @@
               </a:rPr>
               <a:t>AVG TIME TO CLOSE</a:t>
             </a:r>
-            <a:endParaRPr lang="en-US" sz="950" dirty="0"/>
+            <a:endParaRPr lang="en-US" sz="850" dirty="0"/>
           </a:p>
         </p:txBody>
       </p:sp>
       <p:sp>
         <p:nvSpPr>
-          <p:cNvPr id="27" name="Text 25"/>
+          <p:cNvPr id="31" name="Text 29"/>
           <p:cNvSpPr txBox="1"/>
           <p:nvPr/>
         </p:nvSpPr>
         <p:spPr>
           <a:xfrm>
-            <a:off x="9198864" y="1298448"/>
-            <a:ext cx="2432304" cy="356616"/>
+            <a:off x="9219438" y="1444752"/>
+            <a:ext cx="2430018" cy="384048"/>
           </a:xfrm>
           <a:prstGeom prst="rect">
             <a:avLst/>
@@ -2393,7 +2332,7 @@
               <a:buNone/>
             </a:pPr>
             <a:r>
-              <a:rPr lang="en-US" sz="2600" b="1" dirty="0">
+              <a:rPr lang="en-US" sz="2400" b="1" dirty="0">
                 <a:solidFill>
                   <a:srgbClr val="12293A"/>
                 </a:solidFill>
@@ -2403,20 +2342,20 @@
               </a:rPr>
               <a:t>14.0 Days</a:t>
             </a:r>
-            <a:endParaRPr lang="en-US" sz="2600" dirty="0"/>
+            <a:endParaRPr lang="en-US" sz="2400" dirty="0"/>
           </a:p>
         </p:txBody>
       </p:sp>
       <p:sp>
         <p:nvSpPr>
-          <p:cNvPr id="28" name="Text 26"/>
+          <p:cNvPr id="32" name="Text 30"/>
           <p:cNvSpPr txBox="1"/>
           <p:nvPr/>
         </p:nvSpPr>
         <p:spPr>
           <a:xfrm>
-            <a:off x="9217152" y="1691640"/>
-            <a:ext cx="2395728" cy="420624"/>
+            <a:off x="9237726" y="1810512"/>
+            <a:ext cx="2430018" cy="201168"/>
           </a:xfrm>
           <a:prstGeom prst="rect">
             <a:avLst/>
@@ -2425,41 +2364,41 @@
           <a:ln/>
         </p:spPr>
         <p:txBody>
-          <a:bodyPr wrap="square" lIns="0" tIns="0" rIns="0" bIns="0" rtlCol="0" anchor="t"/>
+          <a:bodyPr wrap="square" lIns="0" tIns="0" rIns="0" bIns="0" rtlCol="0" anchor="ctr"/>
           <a:lstStyle/>
           <a:p>
             <a:pPr indent="0" marL="0">
               <a:buNone/>
             </a:pPr>
             <a:r>
-              <a:rPr lang="en-US" sz="780" dirty="0">
-                <a:solidFill>
-                  <a:srgbClr val="5E7280"/>
-                </a:solidFill>
-                <a:latin typeface="Poppins" pitchFamily="34" charset="0"/>
-                <a:ea typeface="Poppins" pitchFamily="34" charset="-122"/>
-                <a:cs typeface="Poppins" pitchFamily="34" charset="-120"/>
-              </a:rPr>
-              <a:t>median 2.1 days · all 597 closed this week · lifted by old tickets cleared</a:t>
-            </a:r>
-            <a:endParaRPr lang="en-US" sz="780" dirty="0"/>
+              <a:rPr lang="en-US" sz="750" dirty="0">
+                <a:solidFill>
+                  <a:srgbClr val="8FA1AC"/>
+                </a:solidFill>
+                <a:latin typeface="Poppins" pitchFamily="34" charset="0"/>
+                <a:ea typeface="Poppins" pitchFamily="34" charset="-122"/>
+                <a:cs typeface="Poppins" pitchFamily="34" charset="-120"/>
+              </a:rPr>
+              <a:t>597 closed this week</a:t>
+            </a:r>
+            <a:endParaRPr lang="en-US" sz="750" dirty="0"/>
           </a:p>
         </p:txBody>
       </p:sp>
       <p:sp>
         <p:nvSpPr>
-          <p:cNvPr id="29" name="Shape 27"/>
+          <p:cNvPr id="33" name="Shape 31"/>
           <p:cNvSpPr/>
           <p:nvPr/>
         </p:nvSpPr>
         <p:spPr>
           <a:xfrm>
-            <a:off x="411480" y="2395728"/>
-            <a:ext cx="6583680" cy="3913632"/>
+            <a:off x="411480" y="2240280"/>
+            <a:ext cx="6583680" cy="4114800"/>
           </a:xfrm>
           <a:prstGeom prst="roundRect">
             <a:avLst>
-              <a:gd name="adj" fmla="val 1636"/>
+              <a:gd name="adj" fmla="val 1556"/>
             </a:avLst>
           </a:prstGeom>
           <a:solidFill>
@@ -2477,13 +2416,13 @@
       </p:sp>
       <p:sp>
         <p:nvSpPr>
-          <p:cNvPr id="30" name="Text 28"/>
+          <p:cNvPr id="34" name="Text 32"/>
           <p:cNvSpPr txBox="1"/>
           <p:nvPr/>
         </p:nvSpPr>
         <p:spPr>
           <a:xfrm>
-            <a:off x="612648" y="2505456"/>
+            <a:off x="612648" y="2350008"/>
             <a:ext cx="6035040" cy="274320"/>
           </a:xfrm>
           <a:prstGeom prst="rect">
@@ -2516,13 +2455,13 @@
       </p:sp>
       <p:graphicFrame>
         <p:nvGraphicFramePr>
-          <p:cNvPr id="31" name="Chart 0" descr=""/>
+          <p:cNvPr id="35" name="Chart 0" descr=""/>
           <p:cNvGraphicFramePr/>
           <p:nvPr/>
         </p:nvGraphicFramePr>
         <p:xfrm>
-          <a:off x="548640" y="2807208"/>
-          <a:ext cx="6309360" cy="3044952"/>
+          <a:off x="548640" y="2624328"/>
+          <a:ext cx="6309360" cy="3383280"/>
         </p:xfrm>
         <a:graphic xmlns:a="http://schemas.openxmlformats.org/drawingml/2006/main">
           <a:graphicData uri="http://schemas.openxmlformats.org/drawingml/2006/chart">
@@ -2532,14 +2471,14 @@
       </p:graphicFrame>
       <p:sp>
         <p:nvSpPr>
-          <p:cNvPr id="32" name="Text 29"/>
+          <p:cNvPr id="36" name="Text 33"/>
           <p:cNvSpPr txBox="1"/>
           <p:nvPr/>
         </p:nvSpPr>
         <p:spPr>
           <a:xfrm>
-            <a:off x="612648" y="5888736"/>
-            <a:ext cx="6181344" cy="384048"/>
+            <a:off x="612648" y="6044184"/>
+            <a:ext cx="6181344" cy="237744"/>
           </a:xfrm>
           <a:prstGeom prst="rect">
             <a:avLst/>
@@ -2555,7 +2494,7 @@
               <a:buNone/>
             </a:pPr>
             <a:r>
-              <a:rPr lang="en-US" sz="620" dirty="0">
+              <a:rPr lang="en-US" sz="630" dirty="0">
                 <a:solidFill>
                   <a:srgbClr val="8FA1AC"/>
                 </a:solidFill>
@@ -2563,26 +2502,26 @@
                 <a:ea typeface="Poppins" pitchFamily="34" charset="-122"/>
                 <a:cs typeface="Poppins" pitchFamily="34" charset="-120"/>
               </a:rPr>
-              <a:t>Support pipeline only · weeks run Mon–Sun, Sydney time · 19 Oct is read to Sunday evening · line = new − closed, right axis: below zero means the backlog shrank. Starts 14 Sep, the first full week after the migration week, whose 1,249 closes were cleanup.</a:t>
-            </a:r>
-            <a:endParaRPr lang="en-US" sz="620" dirty="0"/>
+              <a:t>Support pipeline · Mon–Sun weeks, Sydney time · net = new − closed, below zero = backlog shrank</a:t>
+            </a:r>
+            <a:endParaRPr lang="en-US" sz="630" dirty="0"/>
           </a:p>
         </p:txBody>
       </p:sp>
       <p:sp>
         <p:nvSpPr>
-          <p:cNvPr id="33" name="Shape 30"/>
+          <p:cNvPr id="37" name="Shape 34"/>
           <p:cNvSpPr/>
           <p:nvPr/>
         </p:nvSpPr>
         <p:spPr>
           <a:xfrm>
-            <a:off x="7178040" y="2395728"/>
-            <a:ext cx="4599432" cy="2788920"/>
+            <a:off x="7178040" y="2240280"/>
+            <a:ext cx="4599432" cy="1417320"/>
           </a:xfrm>
           <a:prstGeom prst="roundRect">
             <a:avLst>
-              <a:gd name="adj" fmla="val 2295"/>
+              <a:gd name="adj" fmla="val 4516"/>
             </a:avLst>
           </a:prstGeom>
           <a:solidFill>
@@ -2600,14 +2539,14 @@
       </p:sp>
       <p:sp>
         <p:nvSpPr>
-          <p:cNvPr id="34" name="Text 31"/>
+          <p:cNvPr id="38" name="Text 35"/>
           <p:cNvSpPr txBox="1"/>
           <p:nvPr/>
         </p:nvSpPr>
         <p:spPr>
           <a:xfrm>
-            <a:off x="7379208" y="2505456"/>
-            <a:ext cx="4233672" cy="274320"/>
+            <a:off x="7379208" y="2331720"/>
+            <a:ext cx="4197096" cy="219456"/>
           </a:xfrm>
           <a:prstGeom prst="rect">
             <a:avLst/>
@@ -2623,7 +2562,7 @@
               <a:buNone/>
             </a:pPr>
             <a:r>
-              <a:rPr lang="en-US" sz="1200" b="1" dirty="0">
+              <a:rPr lang="en-US" sz="1000" b="1" dirty="0">
                 <a:solidFill>
                   <a:srgbClr val="2C8394"/>
                 </a:solidFill>
@@ -2631,22 +2570,142 @@
                 <a:ea typeface="Poppins" pitchFamily="34" charset="-122"/>
                 <a:cs typeface="Poppins" pitchFamily="34" charset="-120"/>
               </a:rPr>
-              <a:t>AI SUMMARY</a:t>
-            </a:r>
-            <a:endParaRPr lang="en-US" sz="1200" dirty="0"/>
+              <a:t>WHERE THE 389 OPEN SIT</a:t>
+            </a:r>
+            <a:endParaRPr lang="en-US" sz="1000" dirty="0"/>
           </a:p>
         </p:txBody>
       </p:sp>
       <p:sp>
         <p:nvSpPr>
-          <p:cNvPr id="35" name="Text 32"/>
+          <p:cNvPr id="39" name="Shape 36"/>
+          <p:cNvSpPr/>
+          <p:nvPr/>
+        </p:nvSpPr>
+        <p:spPr>
+          <a:xfrm>
+            <a:off x="7379208" y="2624328"/>
+            <a:ext cx="3002758" cy="109728"/>
+          </a:xfrm>
+          <a:prstGeom prst="rect">
+            <a:avLst/>
+          </a:prstGeom>
+          <a:solidFill>
+            <a:srgbClr val="1B8DA6"/>
+          </a:solidFill>
+          <a:ln/>
+        </p:spPr>
+      </p:sp>
+      <p:sp>
+        <p:nvSpPr>
+          <p:cNvPr id="40" name="Shape 37"/>
+          <p:cNvSpPr/>
+          <p:nvPr/>
+        </p:nvSpPr>
+        <p:spPr>
+          <a:xfrm>
+            <a:off x="10400254" y="2624328"/>
+            <a:ext cx="629079" cy="109728"/>
+          </a:xfrm>
+          <a:prstGeom prst="rect">
+            <a:avLst/>
+          </a:prstGeom>
+          <a:solidFill>
+            <a:srgbClr val="5B7C8A"/>
+          </a:solidFill>
+          <a:ln/>
+        </p:spPr>
+      </p:sp>
+      <p:sp>
+        <p:nvSpPr>
+          <p:cNvPr id="41" name="Shape 38"/>
+          <p:cNvSpPr/>
+          <p:nvPr/>
+        </p:nvSpPr>
+        <p:spPr>
+          <a:xfrm>
+            <a:off x="11047621" y="2624328"/>
+            <a:ext cx="89606" cy="109728"/>
+          </a:xfrm>
+          <a:prstGeom prst="rect">
+            <a:avLst/>
+          </a:prstGeom>
+          <a:solidFill>
+            <a:srgbClr val="E0A458"/>
+          </a:solidFill>
+          <a:ln/>
+        </p:spPr>
+      </p:sp>
+      <p:sp>
+        <p:nvSpPr>
+          <p:cNvPr id="42" name="Shape 39"/>
+          <p:cNvSpPr/>
+          <p:nvPr/>
+        </p:nvSpPr>
+        <p:spPr>
+          <a:xfrm>
+            <a:off x="11155515" y="2624328"/>
+            <a:ext cx="402501" cy="109728"/>
+          </a:xfrm>
+          <a:prstGeom prst="rect">
+            <a:avLst/>
+          </a:prstGeom>
+          <a:solidFill>
+            <a:srgbClr val="C2562A"/>
+          </a:solidFill>
+          <a:ln/>
+        </p:spPr>
+      </p:sp>
+      <p:sp>
+        <p:nvSpPr>
+          <p:cNvPr id="43" name="Shape 40"/>
+          <p:cNvSpPr/>
+          <p:nvPr/>
+        </p:nvSpPr>
+        <p:spPr>
+          <a:xfrm>
+            <a:off x="7379208" y="2843784"/>
+            <a:ext cx="994410" cy="676656"/>
+          </a:xfrm>
+          <a:prstGeom prst="rect">
+            <a:avLst/>
+          </a:prstGeom>
+          <a:solidFill>
+            <a:srgbClr val="F2F6F8"/>
+          </a:solidFill>
+          <a:ln/>
+        </p:spPr>
+      </p:sp>
+      <p:sp>
+        <p:nvSpPr>
+          <p:cNvPr id="44" name="Shape 41"/>
+          <p:cNvSpPr/>
+          <p:nvPr/>
+        </p:nvSpPr>
+        <p:spPr>
+          <a:xfrm>
+            <a:off x="7379208" y="2843784"/>
+            <a:ext cx="994410" cy="45720"/>
+          </a:xfrm>
+          <a:prstGeom prst="rect">
+            <a:avLst/>
+          </a:prstGeom>
+          <a:solidFill>
+            <a:srgbClr val="1B8DA6"/>
+          </a:solidFill>
+          <a:ln/>
+        </p:spPr>
+      </p:sp>
+      <p:sp>
+        <p:nvSpPr>
+          <p:cNvPr id="45" name="Text 42"/>
           <p:cNvSpPr txBox="1"/>
           <p:nvPr/>
         </p:nvSpPr>
         <p:spPr>
           <a:xfrm>
-            <a:off x="7379208" y="2816352"/>
-            <a:ext cx="4187952" cy="2240280"/>
+            <a:off x="7379208" y="2935224"/>
+            <a:ext cx="994410" cy="292608"/>
           </a:xfrm>
           <a:prstGeom prst="rect">
             <a:avLst/>
@@ -2655,28 +2714,14 @@
           <a:ln/>
         </p:spPr>
         <p:txBody>
-          <a:bodyPr wrap="square" lIns="0" tIns="0" rIns="0" bIns="0" rtlCol="0" anchor="t"/>
+          <a:bodyPr wrap="square" lIns="0" tIns="0" rIns="0" bIns="0" rtlCol="0" anchor="ctr"/>
           <a:lstStyle/>
           <a:p>
-            <a:pPr indent="0" marL="0">
-              <a:buNone/>
-            </a:pPr>
-            <a:r>
-              <a:rPr lang="en-US" sz="900" b="1" dirty="0">
-                <a:solidFill>
-                  <a:srgbClr val="3D8F5F"/>
-                </a:solidFill>
-                <a:latin typeface="Poppins" pitchFamily="34" charset="0"/>
-                <a:ea typeface="Poppins" pitchFamily="34" charset="-122"/>
-                <a:cs typeface="Poppins" pitchFamily="34" charset="-120"/>
-              </a:rPr>
-              <a:t>•  </a:t>
-            </a:r>
-            <a:pPr indent="0" marL="0">
-              <a:buNone/>
-            </a:pPr>
-            <a:r>
-              <a:rPr lang="en-US" sz="900" b="1" dirty="0">
+            <a:pPr algn="ctr" indent="0" marL="0">
+              <a:buNone/>
+            </a:pPr>
+            <a:r>
+              <a:rPr lang="en-US" sz="1600" b="1" dirty="0">
                 <a:solidFill>
                   <a:srgbClr val="12293A"/>
                 </a:solidFill>
@@ -2684,47 +2729,134 @@
                 <a:ea typeface="Poppins" pitchFamily="34" charset="-122"/>
                 <a:cs typeface="Poppins" pitchFamily="34" charset="-120"/>
               </a:rPr>
-              <a:t>Closed has beaten new three weeks running. </a:t>
-            </a:r>
-            <a:pPr indent="0" marL="0">
-              <a:spcAft>
-                <a:spcPts val="800"/>
-              </a:spcAft>
-              <a:buNone/>
-            </a:pPr>
-            <a:r>
-              <a:rPr lang="en-US" sz="900" dirty="0">
-                <a:solidFill>
-                  <a:srgbClr val="3A4B57"/>
-                </a:solidFill>
-                <a:latin typeface="Poppins" pitchFamily="34" charset="0"/>
-                <a:ea typeface="Poppins" pitchFamily="34" charset="-122"/>
-                <a:cs typeface="Poppins" pitchFamily="34" charset="-120"/>
-              </a:rPr>
-              <a:t>597 closed against 396 new this week — net −201, the biggest fall since cutover, after −9 and −47. Open is 389, down from 588.</a:t>
-            </a:r>
-            <a:endParaRPr lang="en-US" sz="900" dirty="0"/>
-          </a:p>
-          <a:p>
-            <a:pPr indent="0" marL="0">
-              <a:buNone/>
-            </a:pPr>
-            <a:r>
-              <a:rPr lang="en-US" sz="900" b="1" dirty="0">
-                <a:solidFill>
-                  <a:srgbClr val="C88A2E"/>
-                </a:solidFill>
-                <a:latin typeface="Poppins" pitchFamily="34" charset="0"/>
-                <a:ea typeface="Poppins" pitchFamily="34" charset="-122"/>
-                <a:cs typeface="Poppins" pitchFamily="34" charset="-120"/>
-              </a:rPr>
-              <a:t>•  </a:t>
-            </a:r>
-            <a:pPr indent="0" marL="0">
-              <a:buNone/>
-            </a:pPr>
-            <a:r>
-              <a:rPr lang="en-US" sz="900" b="1" dirty="0">
+              <a:t>280</a:t>
+            </a:r>
+            <a:endParaRPr lang="en-US" sz="1600" dirty="0"/>
+          </a:p>
+        </p:txBody>
+      </p:sp>
+      <p:sp>
+        <p:nvSpPr>
+          <p:cNvPr id="46" name="Text 43"/>
+          <p:cNvSpPr txBox="1"/>
+          <p:nvPr/>
+        </p:nvSpPr>
+        <p:spPr>
+          <a:xfrm>
+            <a:off x="7406640" y="3227832"/>
+            <a:ext cx="939546" cy="256032"/>
+          </a:xfrm>
+          <a:prstGeom prst="rect">
+            <a:avLst/>
+          </a:prstGeom>
+          <a:noFill/>
+          <a:ln/>
+        </p:spPr>
+        <p:txBody>
+          <a:bodyPr wrap="square" lIns="0" tIns="0" rIns="0" bIns="0" rtlCol="0" anchor="ctr"/>
+          <a:lstStyle/>
+          <a:p>
+            <a:pPr algn="ctr" indent="0" marL="0">
+              <a:buNone/>
+            </a:pPr>
+            <a:r>
+              <a:rPr lang="en-US" sz="580" b="1" dirty="0">
+                <a:solidFill>
+                  <a:srgbClr val="5E7280"/>
+                </a:solidFill>
+                <a:latin typeface="Poppins" pitchFamily="34" charset="0"/>
+                <a:ea typeface="Poppins" pitchFamily="34" charset="-122"/>
+                <a:cs typeface="Poppins" pitchFamily="34" charset="-120"/>
+              </a:rPr>
+              <a:t>NEW</a:t>
+            </a:r>
+            <a:endParaRPr lang="en-US" sz="580" dirty="0"/>
+          </a:p>
+          <a:p>
+            <a:pPr algn="ctr" indent="0" marL="0">
+              <a:buNone/>
+            </a:pPr>
+            <a:r>
+              <a:rPr lang="en-US" sz="580" dirty="0">
+                <a:solidFill>
+                  <a:srgbClr val="8FA1AC"/>
+                </a:solidFill>
+                <a:latin typeface="Poppins" pitchFamily="34" charset="0"/>
+                <a:ea typeface="Poppins" pitchFamily="34" charset="-122"/>
+                <a:cs typeface="Poppins" pitchFamily="34" charset="-120"/>
+              </a:rPr>
+              <a:t>72%</a:t>
+            </a:r>
+            <a:endParaRPr lang="en-US" sz="580" dirty="0"/>
+          </a:p>
+        </p:txBody>
+      </p:sp>
+      <p:sp>
+        <p:nvSpPr>
+          <p:cNvPr id="47" name="Shape 44"/>
+          <p:cNvSpPr/>
+          <p:nvPr/>
+        </p:nvSpPr>
+        <p:spPr>
+          <a:xfrm>
+            <a:off x="8446770" y="2843784"/>
+            <a:ext cx="994410" cy="676656"/>
+          </a:xfrm>
+          <a:prstGeom prst="rect">
+            <a:avLst/>
+          </a:prstGeom>
+          <a:solidFill>
+            <a:srgbClr val="F2F6F8"/>
+          </a:solidFill>
+          <a:ln/>
+        </p:spPr>
+      </p:sp>
+      <p:sp>
+        <p:nvSpPr>
+          <p:cNvPr id="48" name="Shape 45"/>
+          <p:cNvSpPr/>
+          <p:nvPr/>
+        </p:nvSpPr>
+        <p:spPr>
+          <a:xfrm>
+            <a:off x="8446770" y="2843784"/>
+            <a:ext cx="994410" cy="45720"/>
+          </a:xfrm>
+          <a:prstGeom prst="rect">
+            <a:avLst/>
+          </a:prstGeom>
+          <a:solidFill>
+            <a:srgbClr val="5B7C8A"/>
+          </a:solidFill>
+          <a:ln/>
+        </p:spPr>
+      </p:sp>
+      <p:sp>
+        <p:nvSpPr>
+          <p:cNvPr id="49" name="Text 46"/>
+          <p:cNvSpPr txBox="1"/>
+          <p:nvPr/>
+        </p:nvSpPr>
+        <p:spPr>
+          <a:xfrm>
+            <a:off x="8446770" y="2935224"/>
+            <a:ext cx="994410" cy="292608"/>
+          </a:xfrm>
+          <a:prstGeom prst="rect">
+            <a:avLst/>
+          </a:prstGeom>
+          <a:noFill/>
+          <a:ln/>
+        </p:spPr>
+        <p:txBody>
+          <a:bodyPr wrap="square" lIns="0" tIns="0" rIns="0" bIns="0" rtlCol="0" anchor="ctr"/>
+          <a:lstStyle/>
+          <a:p>
+            <a:pPr algn="ctr" indent="0" marL="0">
+              <a:buNone/>
+            </a:pPr>
+            <a:r>
+              <a:rPr lang="en-US" sz="1600" b="1" dirty="0">
                 <a:solidFill>
                   <a:srgbClr val="12293A"/>
                 </a:solidFill>
@@ -2732,47 +2864,134 @@
                 <a:ea typeface="Poppins" pitchFamily="34" charset="-122"/>
                 <a:cs typeface="Poppins" pitchFamily="34" charset="-120"/>
               </a:rPr>
-              <a:t>Some of that fall is cleanup. </a:t>
-            </a:r>
-            <a:pPr indent="0" marL="0">
-              <a:spcAft>
-                <a:spcPts val="800"/>
-              </a:spcAft>
-              <a:buNone/>
-            </a:pPr>
-            <a:r>
-              <a:rPr lang="en-US" sz="900" dirty="0">
-                <a:solidFill>
-                  <a:srgbClr val="3A4B57"/>
-                </a:solidFill>
-                <a:latin typeface="Poppins" pitchFamily="34" charset="0"/>
-                <a:ea typeface="Poppins" pitchFamily="34" charset="-122"/>
-                <a:cs typeface="Poppins" pitchFamily="34" charset="-120"/>
-              </a:rPr>
-              <a:t>54 old voice tickets were bulk-closed on Monday evening. Clearing old tickets is also why the average close is 14.0 days while the median is 2.1.</a:t>
-            </a:r>
-            <a:endParaRPr lang="en-US" sz="900" dirty="0"/>
-          </a:p>
-          <a:p>
-            <a:pPr indent="0" marL="0">
-              <a:buNone/>
-            </a:pPr>
-            <a:r>
-              <a:rPr lang="en-US" sz="900" b="1" dirty="0">
-                <a:solidFill>
-                  <a:srgbClr val="2C8394"/>
-                </a:solidFill>
-                <a:latin typeface="Poppins" pitchFamily="34" charset="0"/>
-                <a:ea typeface="Poppins" pitchFamily="34" charset="-122"/>
-                <a:cs typeface="Poppins" pitchFamily="34" charset="-120"/>
-              </a:rPr>
-              <a:t>•  </a:t>
-            </a:r>
-            <a:pPr indent="0" marL="0">
-              <a:buNone/>
-            </a:pPr>
-            <a:r>
-              <a:rPr lang="en-US" sz="900" b="1" dirty="0">
+              <a:t>60</a:t>
+            </a:r>
+            <a:endParaRPr lang="en-US" sz="1600" dirty="0"/>
+          </a:p>
+        </p:txBody>
+      </p:sp>
+      <p:sp>
+        <p:nvSpPr>
+          <p:cNvPr id="50" name="Text 47"/>
+          <p:cNvSpPr txBox="1"/>
+          <p:nvPr/>
+        </p:nvSpPr>
+        <p:spPr>
+          <a:xfrm>
+            <a:off x="8474202" y="3227832"/>
+            <a:ext cx="939546" cy="256032"/>
+          </a:xfrm>
+          <a:prstGeom prst="rect">
+            <a:avLst/>
+          </a:prstGeom>
+          <a:noFill/>
+          <a:ln/>
+        </p:spPr>
+        <p:txBody>
+          <a:bodyPr wrap="square" lIns="0" tIns="0" rIns="0" bIns="0" rtlCol="0" anchor="ctr"/>
+          <a:lstStyle/>
+          <a:p>
+            <a:pPr algn="ctr" indent="0" marL="0">
+              <a:buNone/>
+            </a:pPr>
+            <a:r>
+              <a:rPr lang="en-US" sz="580" b="1" dirty="0">
+                <a:solidFill>
+                  <a:srgbClr val="5E7280"/>
+                </a:solidFill>
+                <a:latin typeface="Poppins" pitchFamily="34" charset="0"/>
+                <a:ea typeface="Poppins" pitchFamily="34" charset="-122"/>
+                <a:cs typeface="Poppins" pitchFamily="34" charset="-120"/>
+              </a:rPr>
+              <a:t>IN PROGRESS</a:t>
+            </a:r>
+            <a:endParaRPr lang="en-US" sz="580" dirty="0"/>
+          </a:p>
+          <a:p>
+            <a:pPr algn="ctr" indent="0" marL="0">
+              <a:buNone/>
+            </a:pPr>
+            <a:r>
+              <a:rPr lang="en-US" sz="580" dirty="0">
+                <a:solidFill>
+                  <a:srgbClr val="8FA1AC"/>
+                </a:solidFill>
+                <a:latin typeface="Poppins" pitchFamily="34" charset="0"/>
+                <a:ea typeface="Poppins" pitchFamily="34" charset="-122"/>
+                <a:cs typeface="Poppins" pitchFamily="34" charset="-120"/>
+              </a:rPr>
+              <a:t>15%</a:t>
+            </a:r>
+            <a:endParaRPr lang="en-US" sz="580" dirty="0"/>
+          </a:p>
+        </p:txBody>
+      </p:sp>
+      <p:sp>
+        <p:nvSpPr>
+          <p:cNvPr id="51" name="Shape 48"/>
+          <p:cNvSpPr/>
+          <p:nvPr/>
+        </p:nvSpPr>
+        <p:spPr>
+          <a:xfrm>
+            <a:off x="9514332" y="2843784"/>
+            <a:ext cx="994410" cy="676656"/>
+          </a:xfrm>
+          <a:prstGeom prst="rect">
+            <a:avLst/>
+          </a:prstGeom>
+          <a:solidFill>
+            <a:srgbClr val="F2F6F8"/>
+          </a:solidFill>
+          <a:ln/>
+        </p:spPr>
+      </p:sp>
+      <p:sp>
+        <p:nvSpPr>
+          <p:cNvPr id="52" name="Shape 49"/>
+          <p:cNvSpPr/>
+          <p:nvPr/>
+        </p:nvSpPr>
+        <p:spPr>
+          <a:xfrm>
+            <a:off x="9514332" y="2843784"/>
+            <a:ext cx="994410" cy="45720"/>
+          </a:xfrm>
+          <a:prstGeom prst="rect">
+            <a:avLst/>
+          </a:prstGeom>
+          <a:solidFill>
+            <a:srgbClr val="E0A458"/>
+          </a:solidFill>
+          <a:ln/>
+        </p:spPr>
+      </p:sp>
+      <p:sp>
+        <p:nvSpPr>
+          <p:cNvPr id="53" name="Text 50"/>
+          <p:cNvSpPr txBox="1"/>
+          <p:nvPr/>
+        </p:nvSpPr>
+        <p:spPr>
+          <a:xfrm>
+            <a:off x="9514332" y="2935224"/>
+            <a:ext cx="994410" cy="292608"/>
+          </a:xfrm>
+          <a:prstGeom prst="rect">
+            <a:avLst/>
+          </a:prstGeom>
+          <a:noFill/>
+          <a:ln/>
+        </p:spPr>
+        <p:txBody>
+          <a:bodyPr wrap="square" lIns="0" tIns="0" rIns="0" bIns="0" rtlCol="0" anchor="ctr"/>
+          <a:lstStyle/>
+          <a:p>
+            <a:pPr algn="ctr" indent="0" marL="0">
+              <a:buNone/>
+            </a:pPr>
+            <a:r>
+              <a:rPr lang="en-US" sz="1600" b="1" dirty="0">
                 <a:solidFill>
                   <a:srgbClr val="12293A"/>
                 </a:solidFill>
@@ -2780,33 +2999,55 @@
                 <a:ea typeface="Poppins" pitchFamily="34" charset="-122"/>
                 <a:cs typeface="Poppins" pitchFamily="34" charset="-120"/>
               </a:rPr>
-              <a:t>First response looks faster, on a thin base. </a:t>
-            </a:r>
-            <a:pPr indent="0" marL="0">
-              <a:spcAft>
-                <a:spcPts val="800"/>
-              </a:spcAft>
-              <a:buNone/>
-            </a:pPr>
-            <a:r>
-              <a:rPr lang="en-US" sz="900" dirty="0">
-                <a:solidFill>
-                  <a:srgbClr val="3A4B57"/>
-                </a:solidFill>
-                <a:latin typeface="Poppins" pitchFamily="34" charset="0"/>
-                <a:ea typeface="Poppins" pitchFamily="34" charset="-122"/>
-                <a:cs typeface="Poppins" pitchFamily="34" charset="-120"/>
-              </a:rPr>
-              <a:t>14.7h on average against 46.8h last week — but only tickets answered by email carry a response time, 14% of new tickets, and ones still waiting aren't counted yet.</a:t>
-            </a:r>
-            <a:endParaRPr lang="en-US" sz="900" dirty="0"/>
-          </a:p>
-          <a:p>
-            <a:pPr indent="0" marL="0">
-              <a:buNone/>
-            </a:pPr>
-            <a:r>
-              <a:rPr lang="en-US" sz="900" b="1" dirty="0">
+              <a:t>10</a:t>
+            </a:r>
+            <a:endParaRPr lang="en-US" sz="1600" dirty="0"/>
+          </a:p>
+        </p:txBody>
+      </p:sp>
+      <p:sp>
+        <p:nvSpPr>
+          <p:cNvPr id="54" name="Text 51"/>
+          <p:cNvSpPr txBox="1"/>
+          <p:nvPr/>
+        </p:nvSpPr>
+        <p:spPr>
+          <a:xfrm>
+            <a:off x="9541764" y="3227832"/>
+            <a:ext cx="939546" cy="256032"/>
+          </a:xfrm>
+          <a:prstGeom prst="rect">
+            <a:avLst/>
+          </a:prstGeom>
+          <a:noFill/>
+          <a:ln/>
+        </p:spPr>
+        <p:txBody>
+          <a:bodyPr wrap="square" lIns="0" tIns="0" rIns="0" bIns="0" rtlCol="0" anchor="ctr"/>
+          <a:lstStyle/>
+          <a:p>
+            <a:pPr algn="ctr" indent="0" marL="0">
+              <a:buNone/>
+            </a:pPr>
+            <a:r>
+              <a:rPr lang="en-US" sz="580" b="1" dirty="0">
+                <a:solidFill>
+                  <a:srgbClr val="5E7280"/>
+                </a:solidFill>
+                <a:latin typeface="Poppins" pitchFamily="34" charset="0"/>
+                <a:ea typeface="Poppins" pitchFamily="34" charset="-122"/>
+                <a:cs typeface="Poppins" pitchFamily="34" charset="-120"/>
+              </a:rPr>
+              <a:t>PENDING INTERNAL</a:t>
+            </a:r>
+            <a:endParaRPr lang="en-US" sz="580" dirty="0"/>
+          </a:p>
+          <a:p>
+            <a:pPr algn="ctr" indent="0" marL="0">
+              <a:buNone/>
+            </a:pPr>
+            <a:r>
+              <a:rPr lang="en-US" sz="580" dirty="0">
                 <a:solidFill>
                   <a:srgbClr val="8FA1AC"/>
                 </a:solidFill>
@@ -2814,16 +3055,134 @@
                 <a:ea typeface="Poppins" pitchFamily="34" charset="-122"/>
                 <a:cs typeface="Poppins" pitchFamily="34" charset="-120"/>
               </a:rPr>
-              <a:t>•  </a:t>
-            </a:r>
-            <a:pPr indent="0" marL="0">
-              <a:spcAft>
-                <a:spcPts val="800"/>
-              </a:spcAft>
-              <a:buNone/>
-            </a:pPr>
-            <a:r>
-              <a:rPr lang="en-US" sz="900" dirty="0">
+              <a:t>3%</a:t>
+            </a:r>
+            <a:endParaRPr lang="en-US" sz="580" dirty="0"/>
+          </a:p>
+        </p:txBody>
+      </p:sp>
+      <p:sp>
+        <p:nvSpPr>
+          <p:cNvPr id="55" name="Shape 52"/>
+          <p:cNvSpPr/>
+          <p:nvPr/>
+        </p:nvSpPr>
+        <p:spPr>
+          <a:xfrm>
+            <a:off x="10581894" y="2843784"/>
+            <a:ext cx="994410" cy="676656"/>
+          </a:xfrm>
+          <a:prstGeom prst="rect">
+            <a:avLst/>
+          </a:prstGeom>
+          <a:solidFill>
+            <a:srgbClr val="F2F6F8"/>
+          </a:solidFill>
+          <a:ln/>
+        </p:spPr>
+      </p:sp>
+      <p:sp>
+        <p:nvSpPr>
+          <p:cNvPr id="56" name="Shape 53"/>
+          <p:cNvSpPr/>
+          <p:nvPr/>
+        </p:nvSpPr>
+        <p:spPr>
+          <a:xfrm>
+            <a:off x="10581894" y="2843784"/>
+            <a:ext cx="994410" cy="45720"/>
+          </a:xfrm>
+          <a:prstGeom prst="rect">
+            <a:avLst/>
+          </a:prstGeom>
+          <a:solidFill>
+            <a:srgbClr val="C2562A"/>
+          </a:solidFill>
+          <a:ln/>
+        </p:spPr>
+      </p:sp>
+      <p:sp>
+        <p:nvSpPr>
+          <p:cNvPr id="57" name="Text 54"/>
+          <p:cNvSpPr txBox="1"/>
+          <p:nvPr/>
+        </p:nvSpPr>
+        <p:spPr>
+          <a:xfrm>
+            <a:off x="10581894" y="2935224"/>
+            <a:ext cx="994410" cy="292608"/>
+          </a:xfrm>
+          <a:prstGeom prst="rect">
+            <a:avLst/>
+          </a:prstGeom>
+          <a:noFill/>
+          <a:ln/>
+        </p:spPr>
+        <p:txBody>
+          <a:bodyPr wrap="square" lIns="0" tIns="0" rIns="0" bIns="0" rtlCol="0" anchor="ctr"/>
+          <a:lstStyle/>
+          <a:p>
+            <a:pPr algn="ctr" indent="0" marL="0">
+              <a:buNone/>
+            </a:pPr>
+            <a:r>
+              <a:rPr lang="en-US" sz="1600" b="1" dirty="0">
+                <a:solidFill>
+                  <a:srgbClr val="12293A"/>
+                </a:solidFill>
+                <a:latin typeface="Poppins" pitchFamily="34" charset="0"/>
+                <a:ea typeface="Poppins" pitchFamily="34" charset="-122"/>
+                <a:cs typeface="Poppins" pitchFamily="34" charset="-120"/>
+              </a:rPr>
+              <a:t>39</a:t>
+            </a:r>
+            <a:endParaRPr lang="en-US" sz="1600" dirty="0"/>
+          </a:p>
+        </p:txBody>
+      </p:sp>
+      <p:sp>
+        <p:nvSpPr>
+          <p:cNvPr id="58" name="Text 55"/>
+          <p:cNvSpPr txBox="1"/>
+          <p:nvPr/>
+        </p:nvSpPr>
+        <p:spPr>
+          <a:xfrm>
+            <a:off x="10609326" y="3227832"/>
+            <a:ext cx="939546" cy="256032"/>
+          </a:xfrm>
+          <a:prstGeom prst="rect">
+            <a:avLst/>
+          </a:prstGeom>
+          <a:noFill/>
+          <a:ln/>
+        </p:spPr>
+        <p:txBody>
+          <a:bodyPr wrap="square" lIns="0" tIns="0" rIns="0" bIns="0" rtlCol="0" anchor="ctr"/>
+          <a:lstStyle/>
+          <a:p>
+            <a:pPr algn="ctr" indent="0" marL="0">
+              <a:buNone/>
+            </a:pPr>
+            <a:r>
+              <a:rPr lang="en-US" sz="580" b="1" dirty="0">
+                <a:solidFill>
+                  <a:srgbClr val="5E7280"/>
+                </a:solidFill>
+                <a:latin typeface="Poppins" pitchFamily="34" charset="0"/>
+                <a:ea typeface="Poppins" pitchFamily="34" charset="-122"/>
+                <a:cs typeface="Poppins" pitchFamily="34" charset="-120"/>
+              </a:rPr>
+              <a:t>PENDING EXTERNAL</a:t>
+            </a:r>
+            <a:endParaRPr lang="en-US" sz="580" dirty="0"/>
+          </a:p>
+          <a:p>
+            <a:pPr algn="ctr" indent="0" marL="0">
+              <a:buNone/>
+            </a:pPr>
+            <a:r>
+              <a:rPr lang="en-US" sz="580" dirty="0">
                 <a:solidFill>
                   <a:srgbClr val="8FA1AC"/>
                 </a:solidFill>
@@ -2831,26 +3190,26 @@
                 <a:ea typeface="Poppins" pitchFamily="34" charset="-122"/>
                 <a:cs typeface="Poppins" pitchFamily="34" charset="-120"/>
               </a:rPr>
-              <a:t>Response time = HubSpot time to first agent email reply; phone and AI-agent tickets have none. Close time = created to closed.</a:t>
-            </a:r>
-            <a:endParaRPr lang="en-US" sz="900" dirty="0"/>
+              <a:t>10%</a:t>
+            </a:r>
+            <a:endParaRPr lang="en-US" sz="580" dirty="0"/>
           </a:p>
         </p:txBody>
       </p:sp>
       <p:sp>
         <p:nvSpPr>
-          <p:cNvPr id="36" name="Shape 33"/>
+          <p:cNvPr id="59" name="Shape 56"/>
           <p:cNvSpPr/>
           <p:nvPr/>
         </p:nvSpPr>
         <p:spPr>
           <a:xfrm>
-            <a:off x="7178040" y="5303520"/>
-            <a:ext cx="4599432" cy="1005840"/>
+            <a:off x="7178040" y="3776472"/>
+            <a:ext cx="4599432" cy="2578608"/>
           </a:xfrm>
           <a:prstGeom prst="roundRect">
             <a:avLst>
-              <a:gd name="adj" fmla="val 6364"/>
+              <a:gd name="adj" fmla="val 2482"/>
             </a:avLst>
           </a:prstGeom>
           <a:solidFill>
@@ -2868,14 +3227,14 @@
       </p:sp>
       <p:sp>
         <p:nvSpPr>
-          <p:cNvPr id="37" name="Text 34"/>
+          <p:cNvPr id="60" name="Text 57"/>
           <p:cNvSpPr txBox="1"/>
           <p:nvPr/>
         </p:nvSpPr>
         <p:spPr>
           <a:xfrm>
-            <a:off x="7379208" y="5394960"/>
-            <a:ext cx="4197096" cy="201168"/>
+            <a:off x="7379208" y="3886200"/>
+            <a:ext cx="4233672" cy="274320"/>
           </a:xfrm>
           <a:prstGeom prst="rect">
             <a:avLst/>
@@ -2891,7 +3250,7 @@
               <a:buNone/>
             </a:pPr>
             <a:r>
-              <a:rPr lang="en-US" sz="950" b="1" dirty="0">
+              <a:rPr lang="en-US" sz="1200" b="1" dirty="0">
                 <a:solidFill>
                   <a:srgbClr val="2C8394"/>
                 </a:solidFill>
@@ -2899,468 +3258,22 @@
                 <a:ea typeface="Poppins" pitchFamily="34" charset="-122"/>
                 <a:cs typeface="Poppins" pitchFamily="34" charset="-120"/>
               </a:rPr>
-              <a:t>WHERE THE 389 OPEN SIT   </a:t>
-            </a:r>
-            <a:pPr indent="0" marL="0">
-              <a:buNone/>
-            </a:pPr>
-            <a:r>
-              <a:rPr lang="en-US" sz="630" dirty="0">
-                <a:solidFill>
-                  <a:srgbClr val="8FA1AC"/>
-                </a:solidFill>
-                <a:latin typeface="Poppins" pitchFamily="34" charset="0"/>
-                <a:ea typeface="Poppins" pitchFamily="34" charset="-122"/>
-                <a:cs typeface="Poppins" pitchFamily="34" charset="-120"/>
-              </a:rPr>
-              <a:t>the two pending states are counted in</a:t>
-            </a:r>
-            <a:endParaRPr lang="en-US" sz="950" dirty="0"/>
+              <a:t>AI SUMMARY</a:t>
+            </a:r>
+            <a:endParaRPr lang="en-US" sz="1200" dirty="0"/>
           </a:p>
         </p:txBody>
       </p:sp>
       <p:sp>
         <p:nvSpPr>
-          <p:cNvPr id="38" name="Shape 35"/>
-          <p:cNvSpPr/>
-          <p:nvPr/>
-        </p:nvSpPr>
-        <p:spPr>
-          <a:xfrm>
-            <a:off x="7379208" y="5632704"/>
-            <a:ext cx="1001268" cy="420624"/>
-          </a:xfrm>
-          <a:prstGeom prst="rect">
-            <a:avLst/>
-          </a:prstGeom>
-          <a:solidFill>
-            <a:srgbClr val="F2F6F8"/>
-          </a:solidFill>
-          <a:ln/>
-        </p:spPr>
-      </p:sp>
-      <p:sp>
-        <p:nvSpPr>
-          <p:cNvPr id="39" name="Text 36"/>
+          <p:cNvPr id="61" name="Text 58"/>
           <p:cNvSpPr txBox="1"/>
           <p:nvPr/>
         </p:nvSpPr>
         <p:spPr>
           <a:xfrm>
-            <a:off x="7470648" y="5660136"/>
-            <a:ext cx="818388" cy="219456"/>
-          </a:xfrm>
-          <a:prstGeom prst="rect">
-            <a:avLst/>
-          </a:prstGeom>
-          <a:noFill/>
-          <a:ln/>
-        </p:spPr>
-        <p:txBody>
-          <a:bodyPr wrap="square" lIns="0" tIns="0" rIns="0" bIns="0" rtlCol="0" anchor="ctr"/>
-          <a:lstStyle/>
-          <a:p>
-            <a:pPr algn="ctr" indent="0" marL="0">
-              <a:buNone/>
-            </a:pPr>
-            <a:r>
-              <a:rPr lang="en-US" sz="1400" b="1" dirty="0">
-                <a:solidFill>
-                  <a:srgbClr val="12293A"/>
-                </a:solidFill>
-                <a:latin typeface="Poppins" pitchFamily="34" charset="0"/>
-                <a:ea typeface="Poppins" pitchFamily="34" charset="-122"/>
-                <a:cs typeface="Poppins" pitchFamily="34" charset="-120"/>
-              </a:rPr>
-              <a:t>280</a:t>
-            </a:r>
-            <a:endParaRPr lang="en-US" sz="1400" dirty="0"/>
-          </a:p>
-        </p:txBody>
-      </p:sp>
-      <p:sp>
-        <p:nvSpPr>
-          <p:cNvPr id="40" name="Text 37"/>
-          <p:cNvSpPr txBox="1"/>
-          <p:nvPr/>
-        </p:nvSpPr>
-        <p:spPr>
-          <a:xfrm>
-            <a:off x="7406640" y="5879592"/>
-            <a:ext cx="946404" cy="155448"/>
-          </a:xfrm>
-          <a:prstGeom prst="rect">
-            <a:avLst/>
-          </a:prstGeom>
-          <a:noFill/>
-          <a:ln/>
-        </p:spPr>
-        <p:txBody>
-          <a:bodyPr wrap="square" lIns="0" tIns="0" rIns="0" bIns="0" rtlCol="0" anchor="ctr"/>
-          <a:lstStyle/>
-          <a:p>
-            <a:pPr algn="ctr" indent="0" marL="0">
-              <a:buNone/>
-            </a:pPr>
-            <a:r>
-              <a:rPr lang="en-US" sz="620" b="1" dirty="0">
-                <a:solidFill>
-                  <a:srgbClr val="5E7280"/>
-                </a:solidFill>
-                <a:latin typeface="Poppins" pitchFamily="34" charset="0"/>
-                <a:ea typeface="Poppins" pitchFamily="34" charset="-122"/>
-                <a:cs typeface="Poppins" pitchFamily="34" charset="-120"/>
-              </a:rPr>
-              <a:t>NEW</a:t>
-            </a:r>
-            <a:endParaRPr lang="en-US" sz="620" dirty="0"/>
-          </a:p>
-        </p:txBody>
-      </p:sp>
-      <p:sp>
-        <p:nvSpPr>
-          <p:cNvPr id="41" name="Shape 38"/>
-          <p:cNvSpPr/>
-          <p:nvPr/>
-        </p:nvSpPr>
-        <p:spPr>
-          <a:xfrm>
-            <a:off x="8444484" y="5632704"/>
-            <a:ext cx="1001268" cy="420624"/>
-          </a:xfrm>
-          <a:prstGeom prst="rect">
-            <a:avLst/>
-          </a:prstGeom>
-          <a:solidFill>
-            <a:srgbClr val="F2F6F8"/>
-          </a:solidFill>
-          <a:ln/>
-        </p:spPr>
-      </p:sp>
-      <p:sp>
-        <p:nvSpPr>
-          <p:cNvPr id="42" name="Text 39"/>
-          <p:cNvSpPr txBox="1"/>
-          <p:nvPr/>
-        </p:nvSpPr>
-        <p:spPr>
-          <a:xfrm>
-            <a:off x="8535924" y="5660136"/>
-            <a:ext cx="818388" cy="219456"/>
-          </a:xfrm>
-          <a:prstGeom prst="rect">
-            <a:avLst/>
-          </a:prstGeom>
-          <a:noFill/>
-          <a:ln/>
-        </p:spPr>
-        <p:txBody>
-          <a:bodyPr wrap="square" lIns="0" tIns="0" rIns="0" bIns="0" rtlCol="0" anchor="ctr"/>
-          <a:lstStyle/>
-          <a:p>
-            <a:pPr algn="ctr" indent="0" marL="0">
-              <a:buNone/>
-            </a:pPr>
-            <a:r>
-              <a:rPr lang="en-US" sz="1400" b="1" dirty="0">
-                <a:solidFill>
-                  <a:srgbClr val="12293A"/>
-                </a:solidFill>
-                <a:latin typeface="Poppins" pitchFamily="34" charset="0"/>
-                <a:ea typeface="Poppins" pitchFamily="34" charset="-122"/>
-                <a:cs typeface="Poppins" pitchFamily="34" charset="-120"/>
-              </a:rPr>
-              <a:t>60</a:t>
-            </a:r>
-            <a:endParaRPr lang="en-US" sz="1400" dirty="0"/>
-          </a:p>
-        </p:txBody>
-      </p:sp>
-      <p:sp>
-        <p:nvSpPr>
-          <p:cNvPr id="43" name="Text 40"/>
-          <p:cNvSpPr txBox="1"/>
-          <p:nvPr/>
-        </p:nvSpPr>
-        <p:spPr>
-          <a:xfrm>
-            <a:off x="8471916" y="5879592"/>
-            <a:ext cx="946404" cy="155448"/>
-          </a:xfrm>
-          <a:prstGeom prst="rect">
-            <a:avLst/>
-          </a:prstGeom>
-          <a:noFill/>
-          <a:ln/>
-        </p:spPr>
-        <p:txBody>
-          <a:bodyPr wrap="square" lIns="0" tIns="0" rIns="0" bIns="0" rtlCol="0" anchor="ctr"/>
-          <a:lstStyle/>
-          <a:p>
-            <a:pPr algn="ctr" indent="0" marL="0">
-              <a:buNone/>
-            </a:pPr>
-            <a:r>
-              <a:rPr lang="en-US" sz="620" b="1" dirty="0">
-                <a:solidFill>
-                  <a:srgbClr val="5E7280"/>
-                </a:solidFill>
-                <a:latin typeface="Poppins" pitchFamily="34" charset="0"/>
-                <a:ea typeface="Poppins" pitchFamily="34" charset="-122"/>
-                <a:cs typeface="Poppins" pitchFamily="34" charset="-120"/>
-              </a:rPr>
-              <a:t>IN PROGRESS</a:t>
-            </a:r>
-            <a:endParaRPr lang="en-US" sz="620" dirty="0"/>
-          </a:p>
-        </p:txBody>
-      </p:sp>
-      <p:sp>
-        <p:nvSpPr>
-          <p:cNvPr id="44" name="Shape 41"/>
-          <p:cNvSpPr/>
-          <p:nvPr/>
-        </p:nvSpPr>
-        <p:spPr>
-          <a:xfrm>
-            <a:off x="9509760" y="5632704"/>
-            <a:ext cx="1001268" cy="420624"/>
-          </a:xfrm>
-          <a:prstGeom prst="rect">
-            <a:avLst/>
-          </a:prstGeom>
-          <a:solidFill>
-            <a:srgbClr val="F7EEDF"/>
-          </a:solidFill>
-          <a:ln/>
-        </p:spPr>
-      </p:sp>
-      <p:sp>
-        <p:nvSpPr>
-          <p:cNvPr id="45" name="Shape 42"/>
-          <p:cNvSpPr/>
-          <p:nvPr/>
-        </p:nvSpPr>
-        <p:spPr>
-          <a:xfrm>
-            <a:off x="9509760" y="5632704"/>
-            <a:ext cx="32004" cy="420624"/>
-          </a:xfrm>
-          <a:prstGeom prst="rect">
-            <a:avLst/>
-          </a:prstGeom>
-          <a:solidFill>
-            <a:srgbClr val="C88A2E"/>
-          </a:solidFill>
-          <a:ln/>
-        </p:spPr>
-      </p:sp>
-      <p:sp>
-        <p:nvSpPr>
-          <p:cNvPr id="46" name="Text 43"/>
-          <p:cNvSpPr txBox="1"/>
-          <p:nvPr/>
-        </p:nvSpPr>
-        <p:spPr>
-          <a:xfrm>
-            <a:off x="9601200" y="5660136"/>
-            <a:ext cx="818388" cy="219456"/>
-          </a:xfrm>
-          <a:prstGeom prst="rect">
-            <a:avLst/>
-          </a:prstGeom>
-          <a:noFill/>
-          <a:ln/>
-        </p:spPr>
-        <p:txBody>
-          <a:bodyPr wrap="square" lIns="0" tIns="0" rIns="0" bIns="0" rtlCol="0" anchor="ctr"/>
-          <a:lstStyle/>
-          <a:p>
-            <a:pPr algn="ctr" indent="0" marL="0">
-              <a:buNone/>
-            </a:pPr>
-            <a:r>
-              <a:rPr lang="en-US" sz="1400" b="1" dirty="0">
-                <a:solidFill>
-                  <a:srgbClr val="C88A2E"/>
-                </a:solidFill>
-                <a:latin typeface="Poppins" pitchFamily="34" charset="0"/>
-                <a:ea typeface="Poppins" pitchFamily="34" charset="-122"/>
-                <a:cs typeface="Poppins" pitchFamily="34" charset="-120"/>
-              </a:rPr>
-              <a:t>10</a:t>
-            </a:r>
-            <a:endParaRPr lang="en-US" sz="1400" dirty="0"/>
-          </a:p>
-        </p:txBody>
-      </p:sp>
-      <p:sp>
-        <p:nvSpPr>
-          <p:cNvPr id="47" name="Text 44"/>
-          <p:cNvSpPr txBox="1"/>
-          <p:nvPr/>
-        </p:nvSpPr>
-        <p:spPr>
-          <a:xfrm>
-            <a:off x="9537192" y="5879592"/>
-            <a:ext cx="946404" cy="155448"/>
-          </a:xfrm>
-          <a:prstGeom prst="rect">
-            <a:avLst/>
-          </a:prstGeom>
-          <a:noFill/>
-          <a:ln/>
-        </p:spPr>
-        <p:txBody>
-          <a:bodyPr wrap="square" lIns="0" tIns="0" rIns="0" bIns="0" rtlCol="0" anchor="ctr"/>
-          <a:lstStyle/>
-          <a:p>
-            <a:pPr algn="ctr" indent="0" marL="0">
-              <a:buNone/>
-            </a:pPr>
-            <a:r>
-              <a:rPr lang="en-US" sz="540" b="1" dirty="0">
-                <a:solidFill>
-                  <a:srgbClr val="C88A2E"/>
-                </a:solidFill>
-                <a:latin typeface="Poppins" pitchFamily="34" charset="0"/>
-                <a:ea typeface="Poppins" pitchFamily="34" charset="-122"/>
-                <a:cs typeface="Poppins" pitchFamily="34" charset="-120"/>
-              </a:rPr>
-              <a:t>PENDING INTERNAL</a:t>
-            </a:r>
-            <a:endParaRPr lang="en-US" sz="540" dirty="0"/>
-          </a:p>
-        </p:txBody>
-      </p:sp>
-      <p:sp>
-        <p:nvSpPr>
-          <p:cNvPr id="48" name="Shape 45"/>
-          <p:cNvSpPr/>
-          <p:nvPr/>
-        </p:nvSpPr>
-        <p:spPr>
-          <a:xfrm>
-            <a:off x="10575036" y="5632704"/>
-            <a:ext cx="1001268" cy="420624"/>
-          </a:xfrm>
-          <a:prstGeom prst="rect">
-            <a:avLst/>
-          </a:prstGeom>
-          <a:solidFill>
-            <a:srgbClr val="F7EEDF"/>
-          </a:solidFill>
-          <a:ln/>
-        </p:spPr>
-      </p:sp>
-      <p:sp>
-        <p:nvSpPr>
-          <p:cNvPr id="49" name="Shape 46"/>
-          <p:cNvSpPr/>
-          <p:nvPr/>
-        </p:nvSpPr>
-        <p:spPr>
-          <a:xfrm>
-            <a:off x="10575036" y="5632704"/>
-            <a:ext cx="32004" cy="420624"/>
-          </a:xfrm>
-          <a:prstGeom prst="rect">
-            <a:avLst/>
-          </a:prstGeom>
-          <a:solidFill>
-            <a:srgbClr val="C88A2E"/>
-          </a:solidFill>
-          <a:ln/>
-        </p:spPr>
-      </p:sp>
-      <p:sp>
-        <p:nvSpPr>
-          <p:cNvPr id="50" name="Text 47"/>
-          <p:cNvSpPr txBox="1"/>
-          <p:nvPr/>
-        </p:nvSpPr>
-        <p:spPr>
-          <a:xfrm>
-            <a:off x="10666476" y="5660136"/>
-            <a:ext cx="818388" cy="219456"/>
-          </a:xfrm>
-          <a:prstGeom prst="rect">
-            <a:avLst/>
-          </a:prstGeom>
-          <a:noFill/>
-          <a:ln/>
-        </p:spPr>
-        <p:txBody>
-          <a:bodyPr wrap="square" lIns="0" tIns="0" rIns="0" bIns="0" rtlCol="0" anchor="ctr"/>
-          <a:lstStyle/>
-          <a:p>
-            <a:pPr algn="ctr" indent="0" marL="0">
-              <a:buNone/>
-            </a:pPr>
-            <a:r>
-              <a:rPr lang="en-US" sz="1400" b="1" dirty="0">
-                <a:solidFill>
-                  <a:srgbClr val="C88A2E"/>
-                </a:solidFill>
-                <a:latin typeface="Poppins" pitchFamily="34" charset="0"/>
-                <a:ea typeface="Poppins" pitchFamily="34" charset="-122"/>
-                <a:cs typeface="Poppins" pitchFamily="34" charset="-120"/>
-              </a:rPr>
-              <a:t>39</a:t>
-            </a:r>
-            <a:endParaRPr lang="en-US" sz="1400" dirty="0"/>
-          </a:p>
-        </p:txBody>
-      </p:sp>
-      <p:sp>
-        <p:nvSpPr>
-          <p:cNvPr id="51" name="Text 48"/>
-          <p:cNvSpPr txBox="1"/>
-          <p:nvPr/>
-        </p:nvSpPr>
-        <p:spPr>
-          <a:xfrm>
-            <a:off x="10602468" y="5879592"/>
-            <a:ext cx="946404" cy="155448"/>
-          </a:xfrm>
-          <a:prstGeom prst="rect">
-            <a:avLst/>
-          </a:prstGeom>
-          <a:noFill/>
-          <a:ln/>
-        </p:spPr>
-        <p:txBody>
-          <a:bodyPr wrap="square" lIns="0" tIns="0" rIns="0" bIns="0" rtlCol="0" anchor="ctr"/>
-          <a:lstStyle/>
-          <a:p>
-            <a:pPr algn="ctr" indent="0" marL="0">
-              <a:buNone/>
-            </a:pPr>
-            <a:r>
-              <a:rPr lang="en-US" sz="540" b="1" dirty="0">
-                <a:solidFill>
-                  <a:srgbClr val="C88A2E"/>
-                </a:solidFill>
-                <a:latin typeface="Poppins" pitchFamily="34" charset="0"/>
-                <a:ea typeface="Poppins" pitchFamily="34" charset="-122"/>
-                <a:cs typeface="Poppins" pitchFamily="34" charset="-120"/>
-              </a:rPr>
-              <a:t>PENDING EXTERNAL</a:t>
-            </a:r>
-            <a:endParaRPr lang="en-US" sz="540" dirty="0"/>
-          </a:p>
-        </p:txBody>
-      </p:sp>
-      <p:sp>
-        <p:nvSpPr>
-          <p:cNvPr id="52" name="Text 49"/>
-          <p:cNvSpPr txBox="1"/>
-          <p:nvPr/>
-        </p:nvSpPr>
-        <p:spPr>
-          <a:xfrm>
-            <a:off x="7379208" y="6099048"/>
-            <a:ext cx="4197096" cy="274320"/>
+            <a:off x="7379208" y="4197096"/>
+            <a:ext cx="4187952" cy="2029968"/>
           </a:xfrm>
           <a:prstGeom prst="rect">
             <a:avLst/>
@@ -3376,23 +3289,184 @@
               <a:buNone/>
             </a:pPr>
             <a:r>
-              <a:rPr lang="en-US" sz="640" dirty="0">
-                <a:solidFill>
-                  <a:srgbClr val="5E7280"/>
-                </a:solidFill>
-                <a:latin typeface="Poppins" pitchFamily="34" charset="0"/>
-                <a:ea typeface="Poppins" pitchFamily="34" charset="-122"/>
-                <a:cs typeface="Poppins" pitchFamily="34" charset="-120"/>
-              </a:rPr>
-              <a:t>Pending Internal and Pending External are inside the 389 — 49 tickets, 13% of it. New is 280, 72% of everything open.</a:t>
-            </a:r>
-            <a:endParaRPr lang="en-US" sz="640" dirty="0"/>
+              <a:rPr lang="en-US" sz="900" b="1" dirty="0">
+                <a:solidFill>
+                  <a:srgbClr val="1B8DA6"/>
+                </a:solidFill>
+                <a:latin typeface="Poppins" pitchFamily="34" charset="0"/>
+                <a:ea typeface="Poppins" pitchFamily="34" charset="-122"/>
+                <a:cs typeface="Poppins" pitchFamily="34" charset="-120"/>
+              </a:rPr>
+              <a:t>•  </a:t>
+            </a:r>
+            <a:pPr indent="0" marL="0">
+              <a:buNone/>
+            </a:pPr>
+            <a:r>
+              <a:rPr lang="en-US" sz="900" b="1" dirty="0">
+                <a:solidFill>
+                  <a:srgbClr val="12293A"/>
+                </a:solidFill>
+                <a:latin typeface="Poppins" pitchFamily="34" charset="0"/>
+                <a:ea typeface="Poppins" pitchFamily="34" charset="-122"/>
+                <a:cs typeface="Poppins" pitchFamily="34" charset="-120"/>
+              </a:rPr>
+              <a:t>Closed has beaten new three weeks running. </a:t>
+            </a:r>
+            <a:pPr indent="0" marL="0">
+              <a:spcAft>
+                <a:spcPts val="800"/>
+              </a:spcAft>
+              <a:buNone/>
+            </a:pPr>
+            <a:r>
+              <a:rPr lang="en-US" sz="900" dirty="0">
+                <a:solidFill>
+                  <a:srgbClr val="3A4B57"/>
+                </a:solidFill>
+                <a:latin typeface="Poppins" pitchFamily="34" charset="0"/>
+                <a:ea typeface="Poppins" pitchFamily="34" charset="-122"/>
+                <a:cs typeface="Poppins" pitchFamily="34" charset="-120"/>
+              </a:rPr>
+              <a:t>597 closed against 396 new this week — net −201, the biggest fall since cutover, after −9 and −47. Open is 389, down from 588.</a:t>
+            </a:r>
+            <a:endParaRPr lang="en-US" sz="900" dirty="0"/>
+          </a:p>
+          <a:p>
+            <a:pPr indent="0" marL="0">
+              <a:buNone/>
+            </a:pPr>
+            <a:r>
+              <a:rPr lang="en-US" sz="900" b="1" dirty="0">
+                <a:solidFill>
+                  <a:srgbClr val="C2562A"/>
+                </a:solidFill>
+                <a:latin typeface="Poppins" pitchFamily="34" charset="0"/>
+                <a:ea typeface="Poppins" pitchFamily="34" charset="-122"/>
+                <a:cs typeface="Poppins" pitchFamily="34" charset="-120"/>
+              </a:rPr>
+              <a:t>•  </a:t>
+            </a:r>
+            <a:pPr indent="0" marL="0">
+              <a:buNone/>
+            </a:pPr>
+            <a:r>
+              <a:rPr lang="en-US" sz="900" b="1" dirty="0">
+                <a:solidFill>
+                  <a:srgbClr val="12293A"/>
+                </a:solidFill>
+                <a:latin typeface="Poppins" pitchFamily="34" charset="0"/>
+                <a:ea typeface="Poppins" pitchFamily="34" charset="-122"/>
+                <a:cs typeface="Poppins" pitchFamily="34" charset="-120"/>
+              </a:rPr>
+              <a:t>Some of that fall is cleanup. </a:t>
+            </a:r>
+            <a:pPr indent="0" marL="0">
+              <a:spcAft>
+                <a:spcPts val="800"/>
+              </a:spcAft>
+              <a:buNone/>
+            </a:pPr>
+            <a:r>
+              <a:rPr lang="en-US" sz="900" dirty="0">
+                <a:solidFill>
+                  <a:srgbClr val="3A4B57"/>
+                </a:solidFill>
+                <a:latin typeface="Poppins" pitchFamily="34" charset="0"/>
+                <a:ea typeface="Poppins" pitchFamily="34" charset="-122"/>
+                <a:cs typeface="Poppins" pitchFamily="34" charset="-120"/>
+              </a:rPr>
+              <a:t>54 old voice tickets were bulk-closed on Monday evening. Clearing old tickets is also why the average close is 14.0 days while the median is 2.1.</a:t>
+            </a:r>
+            <a:endParaRPr lang="en-US" sz="900" dirty="0"/>
+          </a:p>
+          <a:p>
+            <a:pPr indent="0" marL="0">
+              <a:buNone/>
+            </a:pPr>
+            <a:r>
+              <a:rPr lang="en-US" sz="900" b="1" dirty="0">
+                <a:solidFill>
+                  <a:srgbClr val="12293A"/>
+                </a:solidFill>
+                <a:latin typeface="Poppins" pitchFamily="34" charset="0"/>
+                <a:ea typeface="Poppins" pitchFamily="34" charset="-122"/>
+                <a:cs typeface="Poppins" pitchFamily="34" charset="-120"/>
+              </a:rPr>
+              <a:t>•  </a:t>
+            </a:r>
+            <a:pPr indent="0" marL="0">
+              <a:buNone/>
+            </a:pPr>
+            <a:r>
+              <a:rPr lang="en-US" sz="900" b="1" dirty="0">
+                <a:solidFill>
+                  <a:srgbClr val="12293A"/>
+                </a:solidFill>
+                <a:latin typeface="Poppins" pitchFamily="34" charset="0"/>
+                <a:ea typeface="Poppins" pitchFamily="34" charset="-122"/>
+                <a:cs typeface="Poppins" pitchFamily="34" charset="-120"/>
+              </a:rPr>
+              <a:t>First response looks faster, on a thin base. </a:t>
+            </a:r>
+            <a:pPr indent="0" marL="0">
+              <a:spcAft>
+                <a:spcPts val="800"/>
+              </a:spcAft>
+              <a:buNone/>
+            </a:pPr>
+            <a:r>
+              <a:rPr lang="en-US" sz="900" dirty="0">
+                <a:solidFill>
+                  <a:srgbClr val="3A4B57"/>
+                </a:solidFill>
+                <a:latin typeface="Poppins" pitchFamily="34" charset="0"/>
+                <a:ea typeface="Poppins" pitchFamily="34" charset="-122"/>
+                <a:cs typeface="Poppins" pitchFamily="34" charset="-120"/>
+              </a:rPr>
+              <a:t>14.7h on average against 46.8h last week — but only tickets answered by email carry a response time, 14% of new tickets, and ones still waiting aren't counted yet.</a:t>
+            </a:r>
+            <a:endParaRPr lang="en-US" sz="900" dirty="0"/>
+          </a:p>
+          <a:p>
+            <a:pPr indent="0" marL="0">
+              <a:buNone/>
+            </a:pPr>
+            <a:r>
+              <a:rPr lang="en-US" sz="900" b="1" dirty="0">
+                <a:solidFill>
+                  <a:srgbClr val="8FA1AC"/>
+                </a:solidFill>
+                <a:latin typeface="Poppins" pitchFamily="34" charset="0"/>
+                <a:ea typeface="Poppins" pitchFamily="34" charset="-122"/>
+                <a:cs typeface="Poppins" pitchFamily="34" charset="-120"/>
+              </a:rPr>
+              <a:t>•  </a:t>
+            </a:r>
+            <a:pPr indent="0" marL="0">
+              <a:spcAft>
+                <a:spcPts val="800"/>
+              </a:spcAft>
+              <a:buNone/>
+            </a:pPr>
+            <a:r>
+              <a:rPr lang="en-US" sz="900" dirty="0">
+                <a:solidFill>
+                  <a:srgbClr val="8FA1AC"/>
+                </a:solidFill>
+                <a:latin typeface="Poppins" pitchFamily="34" charset="0"/>
+                <a:ea typeface="Poppins" pitchFamily="34" charset="-122"/>
+                <a:cs typeface="Poppins" pitchFamily="34" charset="-120"/>
+              </a:rPr>
+              <a:t>First response = time to first agent email reply; phone and AI-agent tickets have none.</a:t>
+            </a:r>
+            <a:endParaRPr lang="en-US" sz="900" dirty="0"/>
           </a:p>
         </p:txBody>
       </p:sp>
       <p:sp>
         <p:nvSpPr>
-          <p:cNvPr id="53" name="Shape 50"/>
+          <p:cNvPr id="62" name="Shape 59"/>
           <p:cNvSpPr/>
           <p:nvPr/>
         </p:nvSpPr>
@@ -3414,7 +3488,7 @@
       </p:sp>
       <p:sp>
         <p:nvSpPr>
-          <p:cNvPr id="54" name="Text 51"/>
+          <p:cNvPr id="63" name="Text 60"/>
           <p:cNvSpPr txBox="1"/>
           <p:nvPr/>
         </p:nvSpPr>

</xml_diff>

<commit_message>
Support backlog slide: six months of weekly flow, WoW change on every KPI
- Chart now runs 27 Apr to 19 Oct (Support pipeline, Sydney weeks).
  Pre-8-Sep weeks are the Creatio history migrated into HubSpot; they
  match the old Creatio weekly series. The 7 Sep migration week (1,249
  cleanup closes) is left out. Per-bar labels drop when the chart runs
  past 12 weeks.
- Each KPI shows its change from last week: open 588 -> 389, median age
  27 -> 31 days (rebuilt from the open queue at Mon 19 Oct, 590 tickets),
  first response 46.8 -> 14.7 hrs, time to close 8.6 -> 14.0 days
  (exact Sydney weeks, 607 and 597 tickets).

Co-Authored-By: Claude Opus 5.5 <noreply@anthropic.com>
Claude-Session: https://claude.ai/code/session_01Lq5maWicgiSj2RkHzTdcCm
</commit_message>
<xml_diff>
--- a/exec-deck/output/H&L Support Backlog - New vs Closed - WC 19 Oct 2026.pptx
+++ b/exec-deck/output/H&L Support Backlog - New vs Closed - WC 19 Oct 2026.pptx
@@ -157,7 +157,7 @@
               </a:p>
             </c:txPr>
             <c:showLegendKey val="0"/>
-            <c:showVal val="1"/>
+            <c:showVal val="0"/>
             <c:showCatName val="0"/>
             <c:showSerName val="0"/>
             <c:showPercent val="0"/>
@@ -166,26 +166,83 @@
           </c:dLbls>
           <c:cat>
             <c:multiLvlStrRef>
-              <c:f>Sheet1!$A$2:$A$7</c:f>
+              <c:f>Sheet1!$A$2:$A$26</c:f>
               <c:multiLvlStrCache>
-                <c:ptCount val="6"/>
+                <c:ptCount val="25"/>
                 <c:lvl>
                   <c:pt idx="0">
+                    <c:v>27 Apr</c:v>
+                  </c:pt>
+                  <c:pt idx="1">
+                    <c:v>4 May</c:v>
+                  </c:pt>
+                  <c:pt idx="2">
+                    <c:v>11 May</c:v>
+                  </c:pt>
+                  <c:pt idx="3">
+                    <c:v>18 May</c:v>
+                  </c:pt>
+                  <c:pt idx="4">
+                    <c:v>25 May</c:v>
+                  </c:pt>
+                  <c:pt idx="5">
+                    <c:v>1 Jun</c:v>
+                  </c:pt>
+                  <c:pt idx="6">
+                    <c:v>8 Jun</c:v>
+                  </c:pt>
+                  <c:pt idx="7">
+                    <c:v>15 Jun</c:v>
+                  </c:pt>
+                  <c:pt idx="8">
+                    <c:v>22 Jun</c:v>
+                  </c:pt>
+                  <c:pt idx="9">
+                    <c:v>29 Jun</c:v>
+                  </c:pt>
+                  <c:pt idx="10">
+                    <c:v>6 Jul</c:v>
+                  </c:pt>
+                  <c:pt idx="11">
+                    <c:v>13 Jul</c:v>
+                  </c:pt>
+                  <c:pt idx="12">
+                    <c:v>20 Jul</c:v>
+                  </c:pt>
+                  <c:pt idx="13">
+                    <c:v>27 Jul</c:v>
+                  </c:pt>
+                  <c:pt idx="14">
+                    <c:v>3 Aug</c:v>
+                  </c:pt>
+                  <c:pt idx="15">
+                    <c:v>10 Aug</c:v>
+                  </c:pt>
+                  <c:pt idx="16">
+                    <c:v>17 Aug</c:v>
+                  </c:pt>
+                  <c:pt idx="17">
+                    <c:v>24 Aug</c:v>
+                  </c:pt>
+                  <c:pt idx="18">
+                    <c:v>31 Aug</c:v>
+                  </c:pt>
+                  <c:pt idx="19">
                     <c:v>14 Sep</c:v>
                   </c:pt>
-                  <c:pt idx="1">
+                  <c:pt idx="20">
                     <c:v>21 Sep</c:v>
                   </c:pt>
-                  <c:pt idx="2">
+                  <c:pt idx="21">
                     <c:v>28 Sep</c:v>
                   </c:pt>
-                  <c:pt idx="3">
+                  <c:pt idx="22">
                     <c:v>5 Oct</c:v>
                   </c:pt>
-                  <c:pt idx="4">
+                  <c:pt idx="23">
                     <c:v>12 Oct</c:v>
                   </c:pt>
-                  <c:pt idx="5">
+                  <c:pt idx="24">
                     <c:v>19 Oct</c:v>
                   </c:pt>
                 </c:lvl>
@@ -194,26 +251,83 @@
           </c:cat>
           <c:val>
             <c:numRef>
-              <c:f>Sheet1!$B$2:$B$7</c:f>
+              <c:f>Sheet1!$B$2:$B$26</c:f>
               <c:numCache>
                 <c:formatCode>General</c:formatCode>
-                <c:ptCount val="6"/>
+                <c:ptCount val="25"/>
                 <c:pt idx="0">
+                  <c:v>329</c:v>
+                </c:pt>
+                <c:pt idx="1">
+                  <c:v>332</c:v>
+                </c:pt>
+                <c:pt idx="2">
+                  <c:v>391</c:v>
+                </c:pt>
+                <c:pt idx="3">
+                  <c:v>362</c:v>
+                </c:pt>
+                <c:pt idx="4">
+                  <c:v>322</c:v>
+                </c:pt>
+                <c:pt idx="5">
+                  <c:v>325</c:v>
+                </c:pt>
+                <c:pt idx="6">
+                  <c:v>355</c:v>
+                </c:pt>
+                <c:pt idx="7">
+                  <c:v>384</c:v>
+                </c:pt>
+                <c:pt idx="8">
+                  <c:v>324</c:v>
+                </c:pt>
+                <c:pt idx="9">
+                  <c:v>372</c:v>
+                </c:pt>
+                <c:pt idx="10">
+                  <c:v>331</c:v>
+                </c:pt>
+                <c:pt idx="11">
+                  <c:v>333</c:v>
+                </c:pt>
+                <c:pt idx="12">
+                  <c:v>306</c:v>
+                </c:pt>
+                <c:pt idx="13">
+                  <c:v>425</c:v>
+                </c:pt>
+                <c:pt idx="14">
+                  <c:v>432</c:v>
+                </c:pt>
+                <c:pt idx="15">
+                  <c:v>644</c:v>
+                </c:pt>
+                <c:pt idx="16">
+                  <c:v>466</c:v>
+                </c:pt>
+                <c:pt idx="17">
+                  <c:v>412</c:v>
+                </c:pt>
+                <c:pt idx="18">
+                  <c:v>451</c:v>
+                </c:pt>
+                <c:pt idx="19">
                   <c:v>492</c:v>
                 </c:pt>
-                <c:pt idx="1">
+                <c:pt idx="20">
                   <c:v>490</c:v>
                 </c:pt>
-                <c:pt idx="2">
+                <c:pt idx="21">
                   <c:v>450</c:v>
                 </c:pt>
-                <c:pt idx="3">
+                <c:pt idx="22">
                   <c:v>417</c:v>
                 </c:pt>
-                <c:pt idx="4">
+                <c:pt idx="23">
                   <c:v>561</c:v>
                 </c:pt>
-                <c:pt idx="5">
+                <c:pt idx="24">
                   <c:v>396</c:v>
                 </c:pt>
               </c:numCache>
@@ -258,7 +372,7 @@
               </a:p>
             </c:txPr>
             <c:showLegendKey val="0"/>
-            <c:showVal val="1"/>
+            <c:showVal val="0"/>
             <c:showCatName val="0"/>
             <c:showSerName val="0"/>
             <c:showPercent val="0"/>
@@ -267,26 +381,83 @@
           </c:dLbls>
           <c:cat>
             <c:multiLvlStrRef>
-              <c:f>Sheet1!$A$2:$A$7</c:f>
+              <c:f>Sheet1!$A$2:$A$26</c:f>
               <c:multiLvlStrCache>
-                <c:ptCount val="6"/>
+                <c:ptCount val="25"/>
                 <c:lvl>
                   <c:pt idx="0">
+                    <c:v>27 Apr</c:v>
+                  </c:pt>
+                  <c:pt idx="1">
+                    <c:v>4 May</c:v>
+                  </c:pt>
+                  <c:pt idx="2">
+                    <c:v>11 May</c:v>
+                  </c:pt>
+                  <c:pt idx="3">
+                    <c:v>18 May</c:v>
+                  </c:pt>
+                  <c:pt idx="4">
+                    <c:v>25 May</c:v>
+                  </c:pt>
+                  <c:pt idx="5">
+                    <c:v>1 Jun</c:v>
+                  </c:pt>
+                  <c:pt idx="6">
+                    <c:v>8 Jun</c:v>
+                  </c:pt>
+                  <c:pt idx="7">
+                    <c:v>15 Jun</c:v>
+                  </c:pt>
+                  <c:pt idx="8">
+                    <c:v>22 Jun</c:v>
+                  </c:pt>
+                  <c:pt idx="9">
+                    <c:v>29 Jun</c:v>
+                  </c:pt>
+                  <c:pt idx="10">
+                    <c:v>6 Jul</c:v>
+                  </c:pt>
+                  <c:pt idx="11">
+                    <c:v>13 Jul</c:v>
+                  </c:pt>
+                  <c:pt idx="12">
+                    <c:v>20 Jul</c:v>
+                  </c:pt>
+                  <c:pt idx="13">
+                    <c:v>27 Jul</c:v>
+                  </c:pt>
+                  <c:pt idx="14">
+                    <c:v>3 Aug</c:v>
+                  </c:pt>
+                  <c:pt idx="15">
+                    <c:v>10 Aug</c:v>
+                  </c:pt>
+                  <c:pt idx="16">
+                    <c:v>17 Aug</c:v>
+                  </c:pt>
+                  <c:pt idx="17">
+                    <c:v>24 Aug</c:v>
+                  </c:pt>
+                  <c:pt idx="18">
+                    <c:v>31 Aug</c:v>
+                  </c:pt>
+                  <c:pt idx="19">
                     <c:v>14 Sep</c:v>
                   </c:pt>
-                  <c:pt idx="1">
+                  <c:pt idx="20">
                     <c:v>21 Sep</c:v>
                   </c:pt>
-                  <c:pt idx="2">
+                  <c:pt idx="21">
                     <c:v>28 Sep</c:v>
                   </c:pt>
-                  <c:pt idx="3">
+                  <c:pt idx="22">
                     <c:v>5 Oct</c:v>
                   </c:pt>
-                  <c:pt idx="4">
+                  <c:pt idx="23">
                     <c:v>12 Oct</c:v>
                   </c:pt>
-                  <c:pt idx="5">
+                  <c:pt idx="24">
                     <c:v>19 Oct</c:v>
                   </c:pt>
                 </c:lvl>
@@ -295,26 +466,83 @@
           </c:cat>
           <c:val>
             <c:numRef>
-              <c:f>Sheet1!$C$2:$C$7</c:f>
+              <c:f>Sheet1!$C$2:$C$26</c:f>
               <c:numCache>
                 <c:formatCode>General</c:formatCode>
-                <c:ptCount val="6"/>
+                <c:ptCount val="25"/>
                 <c:pt idx="0">
+                  <c:v>281</c:v>
+                </c:pt>
+                <c:pt idx="1">
+                  <c:v>298</c:v>
+                </c:pt>
+                <c:pt idx="2">
+                  <c:v>319</c:v>
+                </c:pt>
+                <c:pt idx="3">
+                  <c:v>287</c:v>
+                </c:pt>
+                <c:pt idx="4">
+                  <c:v>406</c:v>
+                </c:pt>
+                <c:pt idx="5">
+                  <c:v>292</c:v>
+                </c:pt>
+                <c:pt idx="6">
+                  <c:v>371</c:v>
+                </c:pt>
+                <c:pt idx="7">
+                  <c:v>402</c:v>
+                </c:pt>
+                <c:pt idx="8">
+                  <c:v>266</c:v>
+                </c:pt>
+                <c:pt idx="9">
+                  <c:v>315</c:v>
+                </c:pt>
+                <c:pt idx="10">
+                  <c:v>487</c:v>
+                </c:pt>
+                <c:pt idx="11">
+                  <c:v>524</c:v>
+                </c:pt>
+                <c:pt idx="12">
+                  <c:v>329</c:v>
+                </c:pt>
+                <c:pt idx="13">
+                  <c:v>359</c:v>
+                </c:pt>
+                <c:pt idx="14">
+                  <c:v>292</c:v>
+                </c:pt>
+                <c:pt idx="15">
+                  <c:v>465</c:v>
+                </c:pt>
+                <c:pt idx="16">
+                  <c:v>454</c:v>
+                </c:pt>
+                <c:pt idx="17">
+                  <c:v>343</c:v>
+                </c:pt>
+                <c:pt idx="18">
+                  <c:v>347</c:v>
+                </c:pt>
+                <c:pt idx="19">
                   <c:v>607</c:v>
                 </c:pt>
-                <c:pt idx="1">
+                <c:pt idx="20">
                   <c:v>419</c:v>
                 </c:pt>
-                <c:pt idx="2">
+                <c:pt idx="21">
                   <c:v>431</c:v>
                 </c:pt>
-                <c:pt idx="3">
+                <c:pt idx="22">
                   <c:v>426</c:v>
                 </c:pt>
-                <c:pt idx="4">
+                <c:pt idx="23">
                   <c:v>608</c:v>
                 </c:pt>
-                <c:pt idx="5">
+                <c:pt idx="24">
                   <c:v>597</c:v>
                 </c:pt>
               </c:numCache>
@@ -338,15 +566,15 @@
             </a:p>
           </c:txPr>
           <c:showLegendKey val="0"/>
-          <c:showVal val="1"/>
+          <c:showVal val="0"/>
           <c:showCatName val="0"/>
           <c:showSerName val="0"/>
           <c:showPercent val="0"/>
           <c:showBubbleSize val="0"/>
           <c:showLeaderLines val="0"/>
         </c:dLbls>
-        <c:gapWidth val="60"/>
-        <c:overlap val="-8"/>
+        <c:gapWidth val="35"/>
+        <c:overlap val="0"/>
         <c:axId val="2094734554"/>
         <c:axId val="2094734552"/>
         <c:axId val="2094734556"/>
@@ -398,7 +626,7 @@
               </a:p>
             </c:txPr>
             <c:showLegendKey val="0"/>
-            <c:showVal val="1"/>
+            <c:showVal val="0"/>
             <c:showCatName val="0"/>
             <c:showSerName val="0"/>
             <c:showPercent val="0"/>
@@ -407,7 +635,7 @@
           </c:dLbls>
           <c:marker>
             <c:symbol val="circle"/>
-            <c:size val="8"/>
+            <c:size val="5"/>
             <c:spPr>
               <a:solidFill>
                 <a:srgbClr val="C2562A"/>
@@ -424,26 +652,83 @@
           </c:marker>
           <c:cat>
             <c:multiLvlStrRef>
-              <c:f>Sheet1!$A$2:$A$7</c:f>
+              <c:f>Sheet1!$A$2:$A$26</c:f>
               <c:multiLvlStrCache>
-                <c:ptCount val="6"/>
+                <c:ptCount val="25"/>
                 <c:lvl>
                   <c:pt idx="0">
+                    <c:v>27 Apr</c:v>
+                  </c:pt>
+                  <c:pt idx="1">
+                    <c:v>4 May</c:v>
+                  </c:pt>
+                  <c:pt idx="2">
+                    <c:v>11 May</c:v>
+                  </c:pt>
+                  <c:pt idx="3">
+                    <c:v>18 May</c:v>
+                  </c:pt>
+                  <c:pt idx="4">
+                    <c:v>25 May</c:v>
+                  </c:pt>
+                  <c:pt idx="5">
+                    <c:v>1 Jun</c:v>
+                  </c:pt>
+                  <c:pt idx="6">
+                    <c:v>8 Jun</c:v>
+                  </c:pt>
+                  <c:pt idx="7">
+                    <c:v>15 Jun</c:v>
+                  </c:pt>
+                  <c:pt idx="8">
+                    <c:v>22 Jun</c:v>
+                  </c:pt>
+                  <c:pt idx="9">
+                    <c:v>29 Jun</c:v>
+                  </c:pt>
+                  <c:pt idx="10">
+                    <c:v>6 Jul</c:v>
+                  </c:pt>
+                  <c:pt idx="11">
+                    <c:v>13 Jul</c:v>
+                  </c:pt>
+                  <c:pt idx="12">
+                    <c:v>20 Jul</c:v>
+                  </c:pt>
+                  <c:pt idx="13">
+                    <c:v>27 Jul</c:v>
+                  </c:pt>
+                  <c:pt idx="14">
+                    <c:v>3 Aug</c:v>
+                  </c:pt>
+                  <c:pt idx="15">
+                    <c:v>10 Aug</c:v>
+                  </c:pt>
+                  <c:pt idx="16">
+                    <c:v>17 Aug</c:v>
+                  </c:pt>
+                  <c:pt idx="17">
+                    <c:v>24 Aug</c:v>
+                  </c:pt>
+                  <c:pt idx="18">
+                    <c:v>31 Aug</c:v>
+                  </c:pt>
+                  <c:pt idx="19">
                     <c:v>14 Sep</c:v>
                   </c:pt>
-                  <c:pt idx="1">
+                  <c:pt idx="20">
                     <c:v>21 Sep</c:v>
                   </c:pt>
-                  <c:pt idx="2">
+                  <c:pt idx="21">
                     <c:v>28 Sep</c:v>
                   </c:pt>
-                  <c:pt idx="3">
+                  <c:pt idx="22">
                     <c:v>5 Oct</c:v>
                   </c:pt>
-                  <c:pt idx="4">
+                  <c:pt idx="23">
                     <c:v>12 Oct</c:v>
                   </c:pt>
-                  <c:pt idx="5">
+                  <c:pt idx="24">
                     <c:v>19 Oct</c:v>
                   </c:pt>
                 </c:lvl>
@@ -452,26 +737,83 @@
           </c:cat>
           <c:val>
             <c:numRef>
-              <c:f>Sheet1!$D$2:$D$7</c:f>
+              <c:f>Sheet1!$D$2:$D$26</c:f>
               <c:numCache>
                 <c:formatCode>General</c:formatCode>
-                <c:ptCount val="6"/>
+                <c:ptCount val="25"/>
                 <c:pt idx="0">
+                  <c:v>48</c:v>
+                </c:pt>
+                <c:pt idx="1">
+                  <c:v>34</c:v>
+                </c:pt>
+                <c:pt idx="2">
+                  <c:v>72</c:v>
+                </c:pt>
+                <c:pt idx="3">
+                  <c:v>75</c:v>
+                </c:pt>
+                <c:pt idx="4">
+                  <c:v>-84</c:v>
+                </c:pt>
+                <c:pt idx="5">
+                  <c:v>33</c:v>
+                </c:pt>
+                <c:pt idx="6">
+                  <c:v>-16</c:v>
+                </c:pt>
+                <c:pt idx="7">
+                  <c:v>-18</c:v>
+                </c:pt>
+                <c:pt idx="8">
+                  <c:v>58</c:v>
+                </c:pt>
+                <c:pt idx="9">
+                  <c:v>57</c:v>
+                </c:pt>
+                <c:pt idx="10">
+                  <c:v>-156</c:v>
+                </c:pt>
+                <c:pt idx="11">
+                  <c:v>-191</c:v>
+                </c:pt>
+                <c:pt idx="12">
+                  <c:v>-23</c:v>
+                </c:pt>
+                <c:pt idx="13">
+                  <c:v>66</c:v>
+                </c:pt>
+                <c:pt idx="14">
+                  <c:v>140</c:v>
+                </c:pt>
+                <c:pt idx="15">
+                  <c:v>179</c:v>
+                </c:pt>
+                <c:pt idx="16">
+                  <c:v>12</c:v>
+                </c:pt>
+                <c:pt idx="17">
+                  <c:v>69</c:v>
+                </c:pt>
+                <c:pt idx="18">
+                  <c:v>104</c:v>
+                </c:pt>
+                <c:pt idx="19">
                   <c:v>-115</c:v>
                 </c:pt>
-                <c:pt idx="1">
+                <c:pt idx="20">
                   <c:v>71</c:v>
                 </c:pt>
-                <c:pt idx="2">
+                <c:pt idx="21">
                   <c:v>19</c:v>
                 </c:pt>
-                <c:pt idx="3">
+                <c:pt idx="22">
                   <c:v>-9</c:v>
                 </c:pt>
-                <c:pt idx="4">
+                <c:pt idx="23">
                   <c:v>-47</c:v>
                 </c:pt>
-                <c:pt idx="5">
+                <c:pt idx="24">
                   <c:v>-201</c:v>
                 </c:pt>
               </c:numCache>
@@ -496,7 +838,7 @@
             </a:p>
           </c:txPr>
           <c:showLegendKey val="0"/>
-          <c:showVal val="1"/>
+          <c:showVal val="0"/>
           <c:showCatName val="0"/>
           <c:showSerName val="0"/>
           <c:showPercent val="0"/>
@@ -548,6 +890,7 @@
         <c:auto val="1"/>
         <c:lblAlgn val="ctr"/>
         <c:noMultiLvlLbl val="1"/>
+        <c:tickLblSkip val="2"/>
       </c:catAx>
       <c:valAx>
         <c:axId val="2094734552"/>
@@ -1881,7 +2224,7 @@
                 <a:ea typeface="Poppins" pitchFamily="34" charset="-122"/>
                 <a:cs typeface="Poppins" pitchFamily="34" charset="-120"/>
               </a:rPr>
-              <a:t>▼ 199 vs last week</a:t>
+              <a:t>▼ from 588 last week</a:t>
             </a:r>
             <a:endParaRPr lang="en-US" sz="750" dirty="0"/>
           </a:p>
@@ -2039,15 +2382,15 @@
               <a:buNone/>
             </a:pPr>
             <a:r>
-              <a:rPr lang="en-US" sz="750" dirty="0">
-                <a:solidFill>
-                  <a:srgbClr val="8FA1AC"/>
-                </a:solidFill>
-                <a:latin typeface="Poppins" pitchFamily="34" charset="0"/>
-                <a:ea typeface="Poppins" pitchFamily="34" charset="-122"/>
-                <a:cs typeface="Poppins" pitchFamily="34" charset="-120"/>
-              </a:rPr>
-              <a:t>open tickets</a:t>
+              <a:rPr lang="en-US" sz="750" b="1" dirty="0">
+                <a:solidFill>
+                  <a:srgbClr val="B4552D"/>
+                </a:solidFill>
+                <a:latin typeface="Poppins" pitchFamily="34" charset="0"/>
+                <a:ea typeface="Poppins" pitchFamily="34" charset="-122"/>
+                <a:cs typeface="Poppins" pitchFamily="34" charset="-120"/>
+              </a:rPr>
+              <a:t>▲ from 27 days last week</a:t>
             </a:r>
             <a:endParaRPr lang="en-US" sz="750" dirty="0"/>
           </a:p>
@@ -2371,15 +2714,15 @@
               <a:buNone/>
             </a:pPr>
             <a:r>
-              <a:rPr lang="en-US" sz="750" dirty="0">
-                <a:solidFill>
-                  <a:srgbClr val="8FA1AC"/>
-                </a:solidFill>
-                <a:latin typeface="Poppins" pitchFamily="34" charset="0"/>
-                <a:ea typeface="Poppins" pitchFamily="34" charset="-122"/>
-                <a:cs typeface="Poppins" pitchFamily="34" charset="-120"/>
-              </a:rPr>
-              <a:t>597 closed this week</a:t>
+              <a:rPr lang="en-US" sz="750" b="1" dirty="0">
+                <a:solidFill>
+                  <a:srgbClr val="B4552D"/>
+                </a:solidFill>
+                <a:latin typeface="Poppins" pitchFamily="34" charset="0"/>
+                <a:ea typeface="Poppins" pitchFamily="34" charset="-122"/>
+                <a:cs typeface="Poppins" pitchFamily="34" charset="-120"/>
+              </a:rPr>
+              <a:t>▲ from 8.6 days last week</a:t>
             </a:r>
             <a:endParaRPr lang="en-US" sz="750" dirty="0"/>
           </a:p>
@@ -2461,7 +2804,7 @@
         </p:nvGraphicFramePr>
         <p:xfrm>
           <a:off x="548640" y="2624328"/>
-          <a:ext cx="6309360" cy="3383280"/>
+          <a:ext cx="6309360" cy="3364992"/>
         </p:xfrm>
         <a:graphic xmlns:a="http://schemas.openxmlformats.org/drawingml/2006/main">
           <a:graphicData uri="http://schemas.openxmlformats.org/drawingml/2006/chart">
@@ -2477,8 +2820,8 @@
         </p:nvSpPr>
         <p:spPr>
           <a:xfrm>
-            <a:off x="612648" y="6044184"/>
-            <a:ext cx="6181344" cy="237744"/>
+            <a:off x="612648" y="6025896"/>
+            <a:ext cx="6181344" cy="274320"/>
           </a:xfrm>
           <a:prstGeom prst="rect">
             <a:avLst/>
@@ -2502,7 +2845,7 @@
                 <a:ea typeface="Poppins" pitchFamily="34" charset="-122"/>
                 <a:cs typeface="Poppins" pitchFamily="34" charset="-120"/>
               </a:rPr>
-              <a:t>Support pipeline · Mon–Sun weeks, Sydney time · net = new − closed, below zero = backlog shrank</a:t>
+              <a:t>Support pipeline · Mon–Sun weeks, Sydney time · before 8 Sep = history migrated from Creatio · 7 Sep migration week (1,249 cleanup closes) left out · net = new − closed, below zero = backlog shrank</a:t>
             </a:r>
             <a:endParaRPr lang="en-US" sz="630" dirty="0"/>
           </a:p>
@@ -3328,7 +3671,7 @@
                 <a:ea typeface="Poppins" pitchFamily="34" charset="-122"/>
                 <a:cs typeface="Poppins" pitchFamily="34" charset="-120"/>
               </a:rPr>
-              <a:t>597 closed against 396 new this week — net −201, the biggest fall since cutover, after −9 and −47. Open is 389, down from 588.</a:t>
+              <a:t>597 closed against 396 new this week — net −201, the biggest weekly fall in six months. Open is 389, down from 588.</a:t>
             </a:r>
             <a:endParaRPr lang="en-US" sz="900" dirty="0"/>
           </a:p>
@@ -3359,7 +3702,7 @@
                 <a:ea typeface="Poppins" pitchFamily="34" charset="-122"/>
                 <a:cs typeface="Poppins" pitchFamily="34" charset="-120"/>
               </a:rPr>
-              <a:t>Some of that fall is cleanup. </a:t>
+              <a:t>Clearing old tickets pushed the averages up. </a:t>
             </a:r>
             <a:pPr indent="0" marL="0">
               <a:spcAft>
@@ -3376,7 +3719,7 @@
                 <a:ea typeface="Poppins" pitchFamily="34" charset="-122"/>
                 <a:cs typeface="Poppins" pitchFamily="34" charset="-120"/>
               </a:rPr>
-              <a:t>54 old voice tickets were bulk-closed on Monday evening. Clearing old tickets is also why the average close is 14.0 days while the median is 2.1.</a:t>
+              <a:t>54 old voice tickets were bulk-closed on Monday, so average time to close rose from 8.6 to 14.0 days. What's left open is older too: median age 27 → 31 days.</a:t>
             </a:r>
             <a:endParaRPr lang="en-US" sz="900" dirty="0"/>
           </a:p>
@@ -3424,7 +3767,7 @@
                 <a:ea typeface="Poppins" pitchFamily="34" charset="-122"/>
                 <a:cs typeface="Poppins" pitchFamily="34" charset="-120"/>
               </a:rPr>
-              <a:t>14.7h on average against 46.8h last week — but only tickets answered by email carry a response time, 14% of new tickets, and ones still waiting aren't counted yet.</a:t>
+              <a:t>14.7 hrs against 46.8 hrs last week — but only email-answered tickets carry a response time (14% of new tickets), and ones still waiting aren't counted yet.</a:t>
             </a:r>
             <a:endParaRPr lang="en-US" sz="900" dirty="0"/>
           </a:p>

</xml_diff>

<commit_message>
Support backlog slide: add a voice : email box
New Support tickets by the ticket Source field (source_type), phone vs
email: 261 : 120 this week (2.2 : 1) against 420 : 131 last week
(3.2 : 1). 16 tickets with no source or an internal one are left out of
the ratio. The change is shown in a neutral tone, since a higher or lower
ratio is neither good nor bad on its own.

Co-Authored-By: Claude Opus 5.5 <noreply@anthropic.com>
Claude-Session: https://claude.ai/code/session_01Lq5maWicgiSj2RkHzTdcCm
</commit_message>
<xml_diff>
--- a/exec-deck/output/H&L Support Backlog - New vs Closed - WC 19 Oct 2026.pptx
+++ b/exec-deck/output/H&L Support Backlog - New vs Closed - WC 19 Oct 2026.pptx
@@ -2073,7 +2073,7 @@
         <p:spPr>
           <a:xfrm>
             <a:off x="411480" y="1024128"/>
-            <a:ext cx="2704338" cy="1051560"/>
+            <a:ext cx="2126894" cy="1051560"/>
           </a:xfrm>
           <a:prstGeom prst="roundRect">
             <a:avLst>
@@ -2122,7 +2122,7 @@
         <p:spPr>
           <a:xfrm>
             <a:off x="576072" y="1225296"/>
-            <a:ext cx="2430018" cy="219456"/>
+            <a:ext cx="1852574" cy="219456"/>
           </a:xfrm>
           <a:prstGeom prst="rect">
             <a:avLst/>
@@ -2161,7 +2161,7 @@
         <p:spPr>
           <a:xfrm>
             <a:off x="557784" y="1444752"/>
-            <a:ext cx="2430018" cy="384048"/>
+            <a:ext cx="1852574" cy="384048"/>
           </a:xfrm>
           <a:prstGeom prst="rect">
             <a:avLst/>
@@ -2200,7 +2200,7 @@
         <p:spPr>
           <a:xfrm>
             <a:off x="576072" y="1810512"/>
-            <a:ext cx="2430018" cy="201168"/>
+            <a:ext cx="1852574" cy="201168"/>
           </a:xfrm>
           <a:prstGeom prst="rect">
             <a:avLst/>
@@ -2238,8 +2238,8 @@
         </p:nvSpPr>
         <p:spPr>
           <a:xfrm>
-            <a:off x="3298698" y="1024128"/>
-            <a:ext cx="2704338" cy="1051560"/>
+            <a:off x="2721254" y="1024128"/>
+            <a:ext cx="2126894" cy="1051560"/>
           </a:xfrm>
           <a:prstGeom prst="roundRect">
             <a:avLst>
@@ -2267,7 +2267,7 @@
         </p:nvSpPr>
         <p:spPr>
           <a:xfrm>
-            <a:off x="3463290" y="1152144"/>
+            <a:off x="2885846" y="1152144"/>
             <a:ext cx="292608" cy="41148"/>
           </a:xfrm>
           <a:prstGeom prst="rect">
@@ -2287,8 +2287,8 @@
         </p:nvSpPr>
         <p:spPr>
           <a:xfrm>
-            <a:off x="3463290" y="1225296"/>
-            <a:ext cx="2430018" cy="219456"/>
+            <a:off x="2885846" y="1225296"/>
+            <a:ext cx="1852574" cy="219456"/>
           </a:xfrm>
           <a:prstGeom prst="rect">
             <a:avLst/>
@@ -2312,7 +2312,7 @@
                 <a:ea typeface="Poppins" pitchFamily="34" charset="-122"/>
                 <a:cs typeface="Poppins" pitchFamily="34" charset="-120"/>
               </a:rPr>
-              <a:t>MEDIAN TICKET AGE</a:t>
+              <a:t>VOICE : EMAIL</a:t>
             </a:r>
             <a:endParaRPr lang="en-US" sz="850" dirty="0"/>
           </a:p>
@@ -2326,8 +2326,8 @@
         </p:nvSpPr>
         <p:spPr>
           <a:xfrm>
-            <a:off x="3445002" y="1444752"/>
-            <a:ext cx="2430018" cy="384048"/>
+            <a:off x="2867558" y="1444752"/>
+            <a:ext cx="1852574" cy="384048"/>
           </a:xfrm>
           <a:prstGeom prst="rect">
             <a:avLst/>
@@ -2351,7 +2351,7 @@
                 <a:ea typeface="Poppins" pitchFamily="34" charset="-122"/>
                 <a:cs typeface="Poppins" pitchFamily="34" charset="-120"/>
               </a:rPr>
-              <a:t>31 Days</a:t>
+              <a:t>2.2 : 1</a:t>
             </a:r>
             <a:endParaRPr lang="en-US" sz="2400" dirty="0"/>
           </a:p>
@@ -2365,8 +2365,8 @@
         </p:nvSpPr>
         <p:spPr>
           <a:xfrm>
-            <a:off x="3463290" y="1810512"/>
-            <a:ext cx="2430018" cy="201168"/>
+            <a:off x="2885846" y="1810512"/>
+            <a:ext cx="1852574" cy="201168"/>
           </a:xfrm>
           <a:prstGeom prst="rect">
             <a:avLst/>
@@ -2384,13 +2384,13 @@
             <a:r>
               <a:rPr lang="en-US" sz="750" b="1" dirty="0">
                 <a:solidFill>
-                  <a:srgbClr val="B4552D"/>
-                </a:solidFill>
-                <a:latin typeface="Poppins" pitchFamily="34" charset="0"/>
-                <a:ea typeface="Poppins" pitchFamily="34" charset="-122"/>
-                <a:cs typeface="Poppins" pitchFamily="34" charset="-120"/>
-              </a:rPr>
-              <a:t>▲ from 27 days last week</a:t>
+                  <a:srgbClr val="5E7280"/>
+                </a:solidFill>
+                <a:latin typeface="Poppins" pitchFamily="34" charset="0"/>
+                <a:ea typeface="Poppins" pitchFamily="34" charset="-122"/>
+                <a:cs typeface="Poppins" pitchFamily="34" charset="-120"/>
+              </a:rPr>
+              <a:t>▼ from 3.2 : 1 last week</a:t>
             </a:r>
             <a:endParaRPr lang="en-US" sz="750" dirty="0"/>
           </a:p>
@@ -2404,8 +2404,8 @@
         </p:nvSpPr>
         <p:spPr>
           <a:xfrm>
-            <a:off x="6185916" y="1024128"/>
-            <a:ext cx="2704338" cy="1051560"/>
+            <a:off x="5031029" y="1024128"/>
+            <a:ext cx="2126894" cy="1051560"/>
           </a:xfrm>
           <a:prstGeom prst="roundRect">
             <a:avLst>
@@ -2433,7 +2433,7 @@
         </p:nvSpPr>
         <p:spPr>
           <a:xfrm>
-            <a:off x="6350508" y="1152144"/>
+            <a:off x="5195621" y="1152144"/>
             <a:ext cx="292608" cy="41148"/>
           </a:xfrm>
           <a:prstGeom prst="rect">
@@ -2453,8 +2453,8 @@
         </p:nvSpPr>
         <p:spPr>
           <a:xfrm>
-            <a:off x="6350508" y="1225296"/>
-            <a:ext cx="2430018" cy="219456"/>
+            <a:off x="5195621" y="1225296"/>
+            <a:ext cx="1852574" cy="219456"/>
           </a:xfrm>
           <a:prstGeom prst="rect">
             <a:avLst/>
@@ -2478,7 +2478,7 @@
                 <a:ea typeface="Poppins" pitchFamily="34" charset="-122"/>
                 <a:cs typeface="Poppins" pitchFamily="34" charset="-120"/>
               </a:rPr>
-              <a:t>AVG FIRST RESPONSE</a:t>
+              <a:t>MEDIAN TICKET AGE</a:t>
             </a:r>
             <a:endParaRPr lang="en-US" sz="850" dirty="0"/>
           </a:p>
@@ -2492,8 +2492,8 @@
         </p:nvSpPr>
         <p:spPr>
           <a:xfrm>
-            <a:off x="6332220" y="1444752"/>
-            <a:ext cx="2430018" cy="384048"/>
+            <a:off x="5177333" y="1444752"/>
+            <a:ext cx="1852574" cy="384048"/>
           </a:xfrm>
           <a:prstGeom prst="rect">
             <a:avLst/>
@@ -2517,7 +2517,7 @@
                 <a:ea typeface="Poppins" pitchFamily="34" charset="-122"/>
                 <a:cs typeface="Poppins" pitchFamily="34" charset="-120"/>
               </a:rPr>
-              <a:t>14.7 Hrs</a:t>
+              <a:t>31 Days</a:t>
             </a:r>
             <a:endParaRPr lang="en-US" sz="2400" dirty="0"/>
           </a:p>
@@ -2531,8 +2531,8 @@
         </p:nvSpPr>
         <p:spPr>
           <a:xfrm>
-            <a:off x="6350508" y="1810512"/>
-            <a:ext cx="2430018" cy="201168"/>
+            <a:off x="5195621" y="1810512"/>
+            <a:ext cx="1852574" cy="201168"/>
           </a:xfrm>
           <a:prstGeom prst="rect">
             <a:avLst/>
@@ -2550,13 +2550,13 @@
             <a:r>
               <a:rPr lang="en-US" sz="750" b="1" dirty="0">
                 <a:solidFill>
-                  <a:srgbClr val="3D8F5F"/>
-                </a:solidFill>
-                <a:latin typeface="Poppins" pitchFamily="34" charset="0"/>
-                <a:ea typeface="Poppins" pitchFamily="34" charset="-122"/>
-                <a:cs typeface="Poppins" pitchFamily="34" charset="-120"/>
-              </a:rPr>
-              <a:t>▼ from 46.8 hrs last week</a:t>
+                  <a:srgbClr val="B4552D"/>
+                </a:solidFill>
+                <a:latin typeface="Poppins" pitchFamily="34" charset="0"/>
+                <a:ea typeface="Poppins" pitchFamily="34" charset="-122"/>
+                <a:cs typeface="Poppins" pitchFamily="34" charset="-120"/>
+              </a:rPr>
+              <a:t>▲ from 27 days last week</a:t>
             </a:r>
             <a:endParaRPr lang="en-US" sz="750" dirty="0"/>
           </a:p>
@@ -2570,8 +2570,8 @@
         </p:nvSpPr>
         <p:spPr>
           <a:xfrm>
-            <a:off x="9073134" y="1024128"/>
-            <a:ext cx="2704338" cy="1051560"/>
+            <a:off x="7340803" y="1024128"/>
+            <a:ext cx="2126894" cy="1051560"/>
           </a:xfrm>
           <a:prstGeom prst="roundRect">
             <a:avLst>
@@ -2599,7 +2599,7 @@
         </p:nvSpPr>
         <p:spPr>
           <a:xfrm>
-            <a:off x="9237726" y="1152144"/>
+            <a:off x="7505395" y="1152144"/>
             <a:ext cx="292608" cy="41148"/>
           </a:xfrm>
           <a:prstGeom prst="rect">
@@ -2619,8 +2619,8 @@
         </p:nvSpPr>
         <p:spPr>
           <a:xfrm>
-            <a:off x="9237726" y="1225296"/>
-            <a:ext cx="2430018" cy="219456"/>
+            <a:off x="7505395" y="1225296"/>
+            <a:ext cx="1852574" cy="219456"/>
           </a:xfrm>
           <a:prstGeom prst="rect">
             <a:avLst/>
@@ -2644,7 +2644,7 @@
                 <a:ea typeface="Poppins" pitchFamily="34" charset="-122"/>
                 <a:cs typeface="Poppins" pitchFamily="34" charset="-120"/>
               </a:rPr>
-              <a:t>AVG TIME TO CLOSE</a:t>
+              <a:t>AVG FIRST RESPONSE</a:t>
             </a:r>
             <a:endParaRPr lang="en-US" sz="850" dirty="0"/>
           </a:p>
@@ -2658,8 +2658,8 @@
         </p:nvSpPr>
         <p:spPr>
           <a:xfrm>
-            <a:off x="9219438" y="1444752"/>
-            <a:ext cx="2430018" cy="384048"/>
+            <a:off x="7487107" y="1444752"/>
+            <a:ext cx="1852574" cy="384048"/>
           </a:xfrm>
           <a:prstGeom prst="rect">
             <a:avLst/>
@@ -2683,7 +2683,7 @@
                 <a:ea typeface="Poppins" pitchFamily="34" charset="-122"/>
                 <a:cs typeface="Poppins" pitchFamily="34" charset="-120"/>
               </a:rPr>
-              <a:t>14.0 Days</a:t>
+              <a:t>14.7 Hrs</a:t>
             </a:r>
             <a:endParaRPr lang="en-US" sz="2400" dirty="0"/>
           </a:p>
@@ -2697,8 +2697,8 @@
         </p:nvSpPr>
         <p:spPr>
           <a:xfrm>
-            <a:off x="9237726" y="1810512"/>
-            <a:ext cx="2430018" cy="201168"/>
+            <a:off x="7505395" y="1810512"/>
+            <a:ext cx="1852574" cy="201168"/>
           </a:xfrm>
           <a:prstGeom prst="rect">
             <a:avLst/>
@@ -2716,13 +2716,13 @@
             <a:r>
               <a:rPr lang="en-US" sz="750" b="1" dirty="0">
                 <a:solidFill>
-                  <a:srgbClr val="B4552D"/>
-                </a:solidFill>
-                <a:latin typeface="Poppins" pitchFamily="34" charset="0"/>
-                <a:ea typeface="Poppins" pitchFamily="34" charset="-122"/>
-                <a:cs typeface="Poppins" pitchFamily="34" charset="-120"/>
-              </a:rPr>
-              <a:t>▲ from 8.6 days last week</a:t>
+                  <a:srgbClr val="3D8F5F"/>
+                </a:solidFill>
+                <a:latin typeface="Poppins" pitchFamily="34" charset="0"/>
+                <a:ea typeface="Poppins" pitchFamily="34" charset="-122"/>
+                <a:cs typeface="Poppins" pitchFamily="34" charset="-120"/>
+              </a:rPr>
+              <a:t>▼ from 46.8 hrs last week</a:t>
             </a:r>
             <a:endParaRPr lang="en-US" sz="750" dirty="0"/>
           </a:p>
@@ -2736,12 +2736,12 @@
         </p:nvSpPr>
         <p:spPr>
           <a:xfrm>
-            <a:off x="411480" y="2240280"/>
-            <a:ext cx="6583680" cy="4114800"/>
+            <a:off x="9650578" y="1024128"/>
+            <a:ext cx="2126894" cy="1051560"/>
           </a:xfrm>
           <a:prstGeom prst="roundRect">
             <a:avLst>
-              <a:gd name="adj" fmla="val 1556"/>
+              <a:gd name="adj" fmla="val 6087"/>
             </a:avLst>
           </a:prstGeom>
           <a:solidFill>
@@ -2759,14 +2759,34 @@
       </p:sp>
       <p:sp>
         <p:nvSpPr>
-          <p:cNvPr id="34" name="Text 32"/>
+          <p:cNvPr id="34" name="Shape 32"/>
+          <p:cNvSpPr/>
+          <p:nvPr/>
+        </p:nvSpPr>
+        <p:spPr>
+          <a:xfrm>
+            <a:off x="9815170" y="1152144"/>
+            <a:ext cx="292608" cy="41148"/>
+          </a:xfrm>
+          <a:prstGeom prst="rect">
+            <a:avLst/>
+          </a:prstGeom>
+          <a:solidFill>
+            <a:srgbClr val="1B8DA6"/>
+          </a:solidFill>
+          <a:ln/>
+        </p:spPr>
+      </p:sp>
+      <p:sp>
+        <p:nvSpPr>
+          <p:cNvPr id="35" name="Text 33"/>
           <p:cNvSpPr txBox="1"/>
           <p:nvPr/>
         </p:nvSpPr>
         <p:spPr>
           <a:xfrm>
-            <a:off x="612648" y="2350008"/>
-            <a:ext cx="6035040" cy="274320"/>
+            <a:off x="9815170" y="1225296"/>
+            <a:ext cx="1852574" cy="219456"/>
           </a:xfrm>
           <a:prstGeom prst="rect">
             <a:avLst/>
@@ -2782,6 +2802,152 @@
               <a:buNone/>
             </a:pPr>
             <a:r>
+              <a:rPr lang="en-US" sz="850" b="1" dirty="0">
+                <a:solidFill>
+                  <a:srgbClr val="5E7280"/>
+                </a:solidFill>
+                <a:latin typeface="Poppins" pitchFamily="34" charset="0"/>
+                <a:ea typeface="Poppins" pitchFamily="34" charset="-122"/>
+                <a:cs typeface="Poppins" pitchFamily="34" charset="-120"/>
+              </a:rPr>
+              <a:t>AVG TIME TO CLOSE</a:t>
+            </a:r>
+            <a:endParaRPr lang="en-US" sz="850" dirty="0"/>
+          </a:p>
+        </p:txBody>
+      </p:sp>
+      <p:sp>
+        <p:nvSpPr>
+          <p:cNvPr id="36" name="Text 34"/>
+          <p:cNvSpPr txBox="1"/>
+          <p:nvPr/>
+        </p:nvSpPr>
+        <p:spPr>
+          <a:xfrm>
+            <a:off x="9796882" y="1444752"/>
+            <a:ext cx="1852574" cy="384048"/>
+          </a:xfrm>
+          <a:prstGeom prst="rect">
+            <a:avLst/>
+          </a:prstGeom>
+          <a:noFill/>
+          <a:ln/>
+        </p:spPr>
+        <p:txBody>
+          <a:bodyPr wrap="square" lIns="0" tIns="0" rIns="0" bIns="0" rtlCol="0" anchor="ctr"/>
+          <a:lstStyle/>
+          <a:p>
+            <a:pPr indent="0" marL="0">
+              <a:buNone/>
+            </a:pPr>
+            <a:r>
+              <a:rPr lang="en-US" sz="2400" b="1" dirty="0">
+                <a:solidFill>
+                  <a:srgbClr val="12293A"/>
+                </a:solidFill>
+                <a:latin typeface="Poppins" pitchFamily="34" charset="0"/>
+                <a:ea typeface="Poppins" pitchFamily="34" charset="-122"/>
+                <a:cs typeface="Poppins" pitchFamily="34" charset="-120"/>
+              </a:rPr>
+              <a:t>14.0 Days</a:t>
+            </a:r>
+            <a:endParaRPr lang="en-US" sz="2400" dirty="0"/>
+          </a:p>
+        </p:txBody>
+      </p:sp>
+      <p:sp>
+        <p:nvSpPr>
+          <p:cNvPr id="37" name="Text 35"/>
+          <p:cNvSpPr txBox="1"/>
+          <p:nvPr/>
+        </p:nvSpPr>
+        <p:spPr>
+          <a:xfrm>
+            <a:off x="9815170" y="1810512"/>
+            <a:ext cx="1852574" cy="201168"/>
+          </a:xfrm>
+          <a:prstGeom prst="rect">
+            <a:avLst/>
+          </a:prstGeom>
+          <a:noFill/>
+          <a:ln/>
+        </p:spPr>
+        <p:txBody>
+          <a:bodyPr wrap="square" lIns="0" tIns="0" rIns="0" bIns="0" rtlCol="0" anchor="ctr"/>
+          <a:lstStyle/>
+          <a:p>
+            <a:pPr indent="0" marL="0">
+              <a:buNone/>
+            </a:pPr>
+            <a:r>
+              <a:rPr lang="en-US" sz="750" b="1" dirty="0">
+                <a:solidFill>
+                  <a:srgbClr val="B4552D"/>
+                </a:solidFill>
+                <a:latin typeface="Poppins" pitchFamily="34" charset="0"/>
+                <a:ea typeface="Poppins" pitchFamily="34" charset="-122"/>
+                <a:cs typeface="Poppins" pitchFamily="34" charset="-120"/>
+              </a:rPr>
+              <a:t>▲ from 8.6 days last week</a:t>
+            </a:r>
+            <a:endParaRPr lang="en-US" sz="750" dirty="0"/>
+          </a:p>
+        </p:txBody>
+      </p:sp>
+      <p:sp>
+        <p:nvSpPr>
+          <p:cNvPr id="38" name="Shape 36"/>
+          <p:cNvSpPr/>
+          <p:nvPr/>
+        </p:nvSpPr>
+        <p:spPr>
+          <a:xfrm>
+            <a:off x="411480" y="2240280"/>
+            <a:ext cx="6583680" cy="4114800"/>
+          </a:xfrm>
+          <a:prstGeom prst="roundRect">
+            <a:avLst>
+              <a:gd name="adj" fmla="val 1556"/>
+            </a:avLst>
+          </a:prstGeom>
+          <a:solidFill>
+            <a:srgbClr val="FFFFFF"/>
+          </a:solidFill>
+          <a:ln/>
+          <a:effectLst>
+            <a:outerShdw sx="100000" sy="100000" kx="0" ky="0" algn="bl" rotWithShape="0" blurRad="76200" dist="25400" dir="5400000">
+              <a:srgbClr val="9AAAB5">
+                <a:alpha val="35000"/>
+              </a:srgbClr>
+            </a:outerShdw>
+          </a:effectLst>
+        </p:spPr>
+      </p:sp>
+      <p:sp>
+        <p:nvSpPr>
+          <p:cNvPr id="39" name="Text 37"/>
+          <p:cNvSpPr txBox="1"/>
+          <p:nvPr/>
+        </p:nvSpPr>
+        <p:spPr>
+          <a:xfrm>
+            <a:off x="612648" y="2350008"/>
+            <a:ext cx="6035040" cy="274320"/>
+          </a:xfrm>
+          <a:prstGeom prst="rect">
+            <a:avLst/>
+          </a:prstGeom>
+          <a:noFill/>
+          <a:ln/>
+        </p:spPr>
+        <p:txBody>
+          <a:bodyPr wrap="square" lIns="0" tIns="0" rIns="0" bIns="0" rtlCol="0" anchor="ctr"/>
+          <a:lstStyle/>
+          <a:p>
+            <a:pPr indent="0" marL="0">
+              <a:buNone/>
+            </a:pPr>
+            <a:r>
               <a:rPr lang="en-US" sz="1200" b="1" dirty="0">
                 <a:solidFill>
                   <a:srgbClr val="2C8394"/>
@@ -2798,7 +2964,7 @@
       </p:sp>
       <p:graphicFrame>
         <p:nvGraphicFramePr>
-          <p:cNvPr id="35" name="Chart 0" descr=""/>
+          <p:cNvPr id="40" name="Chart 0" descr=""/>
           <p:cNvGraphicFramePr/>
           <p:nvPr/>
         </p:nvGraphicFramePr>
@@ -2814,7 +2980,7 @@
       </p:graphicFrame>
       <p:sp>
         <p:nvSpPr>
-          <p:cNvPr id="36" name="Text 33"/>
+          <p:cNvPr id="41" name="Text 38"/>
           <p:cNvSpPr txBox="1"/>
           <p:nvPr/>
         </p:nvSpPr>
@@ -2853,7 +3019,7 @@
       </p:sp>
       <p:sp>
         <p:nvSpPr>
-          <p:cNvPr id="37" name="Shape 34"/>
+          <p:cNvPr id="42" name="Shape 39"/>
           <p:cNvSpPr/>
           <p:nvPr/>
         </p:nvSpPr>
@@ -2882,7 +3048,7 @@
       </p:sp>
       <p:sp>
         <p:nvSpPr>
-          <p:cNvPr id="38" name="Text 35"/>
+          <p:cNvPr id="43" name="Text 40"/>
           <p:cNvSpPr txBox="1"/>
           <p:nvPr/>
         </p:nvSpPr>
@@ -2921,7 +3087,7 @@
       </p:sp>
       <p:sp>
         <p:nvSpPr>
-          <p:cNvPr id="39" name="Shape 36"/>
+          <p:cNvPr id="44" name="Shape 41"/>
           <p:cNvSpPr/>
           <p:nvPr/>
         </p:nvSpPr>
@@ -2941,7 +3107,7 @@
       </p:sp>
       <p:sp>
         <p:nvSpPr>
-          <p:cNvPr id="40" name="Shape 37"/>
+          <p:cNvPr id="45" name="Shape 42"/>
           <p:cNvSpPr/>
           <p:nvPr/>
         </p:nvSpPr>
@@ -2961,7 +3127,7 @@
       </p:sp>
       <p:sp>
         <p:nvSpPr>
-          <p:cNvPr id="41" name="Shape 38"/>
+          <p:cNvPr id="46" name="Shape 43"/>
           <p:cNvSpPr/>
           <p:nvPr/>
         </p:nvSpPr>
@@ -2981,7 +3147,7 @@
       </p:sp>
       <p:sp>
         <p:nvSpPr>
-          <p:cNvPr id="42" name="Shape 39"/>
+          <p:cNvPr id="47" name="Shape 44"/>
           <p:cNvSpPr/>
           <p:nvPr/>
         </p:nvSpPr>
@@ -3001,7 +3167,7 @@
       </p:sp>
       <p:sp>
         <p:nvSpPr>
-          <p:cNvPr id="43" name="Shape 40"/>
+          <p:cNvPr id="48" name="Shape 45"/>
           <p:cNvSpPr/>
           <p:nvPr/>
         </p:nvSpPr>
@@ -3021,7 +3187,7 @@
       </p:sp>
       <p:sp>
         <p:nvSpPr>
-          <p:cNvPr id="44" name="Shape 41"/>
+          <p:cNvPr id="49" name="Shape 46"/>
           <p:cNvSpPr/>
           <p:nvPr/>
         </p:nvSpPr>
@@ -3041,7 +3207,7 @@
       </p:sp>
       <p:sp>
         <p:nvSpPr>
-          <p:cNvPr id="45" name="Text 42"/>
+          <p:cNvPr id="50" name="Text 47"/>
           <p:cNvSpPr txBox="1"/>
           <p:nvPr/>
         </p:nvSpPr>
@@ -3080,7 +3246,7 @@
       </p:sp>
       <p:sp>
         <p:nvSpPr>
-          <p:cNvPr id="46" name="Text 43"/>
+          <p:cNvPr id="51" name="Text 48"/>
           <p:cNvSpPr txBox="1"/>
           <p:nvPr/>
         </p:nvSpPr>
@@ -3136,7 +3302,7 @@
       </p:sp>
       <p:sp>
         <p:nvSpPr>
-          <p:cNvPr id="47" name="Shape 44"/>
+          <p:cNvPr id="52" name="Shape 49"/>
           <p:cNvSpPr/>
           <p:nvPr/>
         </p:nvSpPr>
@@ -3156,7 +3322,7 @@
       </p:sp>
       <p:sp>
         <p:nvSpPr>
-          <p:cNvPr id="48" name="Shape 45"/>
+          <p:cNvPr id="53" name="Shape 50"/>
           <p:cNvSpPr/>
           <p:nvPr/>
         </p:nvSpPr>
@@ -3176,7 +3342,7 @@
       </p:sp>
       <p:sp>
         <p:nvSpPr>
-          <p:cNvPr id="49" name="Text 46"/>
+          <p:cNvPr id="54" name="Text 51"/>
           <p:cNvSpPr txBox="1"/>
           <p:nvPr/>
         </p:nvSpPr>
@@ -3215,7 +3381,7 @@
       </p:sp>
       <p:sp>
         <p:nvSpPr>
-          <p:cNvPr id="50" name="Text 47"/>
+          <p:cNvPr id="55" name="Text 52"/>
           <p:cNvSpPr txBox="1"/>
           <p:nvPr/>
         </p:nvSpPr>
@@ -3271,7 +3437,7 @@
       </p:sp>
       <p:sp>
         <p:nvSpPr>
-          <p:cNvPr id="51" name="Shape 48"/>
+          <p:cNvPr id="56" name="Shape 53"/>
           <p:cNvSpPr/>
           <p:nvPr/>
         </p:nvSpPr>
@@ -3291,7 +3457,7 @@
       </p:sp>
       <p:sp>
         <p:nvSpPr>
-          <p:cNvPr id="52" name="Shape 49"/>
+          <p:cNvPr id="57" name="Shape 54"/>
           <p:cNvSpPr/>
           <p:nvPr/>
         </p:nvSpPr>
@@ -3311,7 +3477,7 @@
       </p:sp>
       <p:sp>
         <p:nvSpPr>
-          <p:cNvPr id="53" name="Text 50"/>
+          <p:cNvPr id="58" name="Text 55"/>
           <p:cNvSpPr txBox="1"/>
           <p:nvPr/>
         </p:nvSpPr>
@@ -3350,7 +3516,7 @@
       </p:sp>
       <p:sp>
         <p:nvSpPr>
-          <p:cNvPr id="54" name="Text 51"/>
+          <p:cNvPr id="59" name="Text 56"/>
           <p:cNvSpPr txBox="1"/>
           <p:nvPr/>
         </p:nvSpPr>
@@ -3406,7 +3572,7 @@
       </p:sp>
       <p:sp>
         <p:nvSpPr>
-          <p:cNvPr id="55" name="Shape 52"/>
+          <p:cNvPr id="60" name="Shape 57"/>
           <p:cNvSpPr/>
           <p:nvPr/>
         </p:nvSpPr>
@@ -3426,7 +3592,7 @@
       </p:sp>
       <p:sp>
         <p:nvSpPr>
-          <p:cNvPr id="56" name="Shape 53"/>
+          <p:cNvPr id="61" name="Shape 58"/>
           <p:cNvSpPr/>
           <p:nvPr/>
         </p:nvSpPr>
@@ -3446,7 +3612,7 @@
       </p:sp>
       <p:sp>
         <p:nvSpPr>
-          <p:cNvPr id="57" name="Text 54"/>
+          <p:cNvPr id="62" name="Text 59"/>
           <p:cNvSpPr txBox="1"/>
           <p:nvPr/>
         </p:nvSpPr>
@@ -3485,7 +3651,7 @@
       </p:sp>
       <p:sp>
         <p:nvSpPr>
-          <p:cNvPr id="58" name="Text 55"/>
+          <p:cNvPr id="63" name="Text 60"/>
           <p:cNvSpPr txBox="1"/>
           <p:nvPr/>
         </p:nvSpPr>
@@ -3541,7 +3707,7 @@
       </p:sp>
       <p:sp>
         <p:nvSpPr>
-          <p:cNvPr id="59" name="Shape 56"/>
+          <p:cNvPr id="64" name="Shape 61"/>
           <p:cNvSpPr/>
           <p:nvPr/>
         </p:nvSpPr>
@@ -3570,7 +3736,7 @@
       </p:sp>
       <p:sp>
         <p:nvSpPr>
-          <p:cNvPr id="60" name="Text 57"/>
+          <p:cNvPr id="65" name="Text 62"/>
           <p:cNvSpPr txBox="1"/>
           <p:nvPr/>
         </p:nvSpPr>
@@ -3609,7 +3775,7 @@
       </p:sp>
       <p:sp>
         <p:nvSpPr>
-          <p:cNvPr id="61" name="Text 58"/>
+          <p:cNvPr id="66" name="Text 63"/>
           <p:cNvSpPr txBox="1"/>
           <p:nvPr/>
         </p:nvSpPr>
@@ -3801,7 +3967,7 @@
                 <a:ea typeface="Poppins" pitchFamily="34" charset="-122"/>
                 <a:cs typeface="Poppins" pitchFamily="34" charset="-120"/>
               </a:rPr>
-              <a:t>First response = time to first agent email reply; phone and AI-agent tickets have none.</a:t>
+              <a:t>Voice : email = new tickets by Source, phone vs email. First response = time to first agent email reply; phone and AI-agent tickets have none.</a:t>
             </a:r>
             <a:endParaRPr lang="en-US" sz="900" dirty="0"/>
           </a:p>
@@ -3809,7 +3975,7 @@
       </p:sp>
       <p:sp>
         <p:nvSpPr>
-          <p:cNvPr id="62" name="Shape 59"/>
+          <p:cNvPr id="67" name="Shape 64"/>
           <p:cNvSpPr/>
           <p:nvPr/>
         </p:nvSpPr>
@@ -3831,7 +3997,7 @@
       </p:sp>
       <p:sp>
         <p:nvSpPr>
-          <p:cNvPr id="63" name="Text 60"/>
+          <p:cNvPr id="68" name="Text 65"/>
           <p:cNvSpPr txBox="1"/>
           <p:nvPr/>
         </p:nvSpPr>

</xml_diff>